<commit_message>
docs(pitch-deck): remove Devanagari Hindi text and integrate 5-tier System Architecture from README into 10-slide deck
</commit_message>
<xml_diff>
--- a/Pitch-DECK/Sanjeevini-Pitch-Deck.pptx
+++ b/Pitch-DECK/Sanjeevini-Pitch-Deck.pptx
@@ -3181,14 +3181,14 @@
               <a:spcAft>
                 <a:spcPts val="800"/>
               </a:spcAft>
-              <a:defRPr sz="3800" b="1">
+              <a:defRPr sz="4400" b="1">
                 <a:solidFill>
                   <a:srgbClr val="0F172A"/>
                 </a:solidFill>
               </a:defRPr>
             </a:pPr>
             <a:r>
-              <a:t>संजीविनी (Sanjeevini)</a:t>
+              <a:t>Sanjeevini</a:t>
             </a:r>
           </a:p>
           <a:p>
@@ -3280,7 +3280,7 @@
               </a:defRPr>
             </a:pPr>
             <a:r>
-              <a:t>संजीविनी (Sanjeevini) | National Health Resource &amp; Supply Chain Resilience Platform   •   Slide 1 of 10</a:t>
+              <a:t>Sanjeevini | National Health Resource &amp; Supply Chain Resilience Platform   •   Slide 1 of 10</a:t>
             </a:r>
           </a:p>
         </p:txBody>
@@ -3336,7 +3336,7 @@
               </a:defRPr>
             </a:pPr>
             <a:r>
-              <a:t>ENTERPRISE SCALING &amp; ABDM INTEGRATION</a:t>
+              <a:t>MEASURABLE OUTCOMES &amp; SCALING ROADMAP</a:t>
             </a:r>
           </a:p>
           <a:p>
@@ -3348,7 +3348,7 @@
               </a:defRPr>
             </a:pPr>
             <a:r>
-              <a:t>National Scale Deployment Roadmap &amp; Long-Term Vision</a:t>
+              <a:t>Transformative Impact Benchmarks &amp; National Deployment</a:t>
             </a:r>
           </a:p>
         </p:txBody>
@@ -3361,8 +3361,8 @@
         </p:nvSpPr>
         <p:spPr>
           <a:xfrm>
-            <a:off x="731520" y="1463040"/>
-            <a:ext cx="3337560" cy="3657600"/>
+            <a:off x="731520" y="1371600"/>
+            <a:ext cx="2468880" cy="1371600"/>
           </a:xfrm>
           <a:prstGeom prst="roundRect">
             <a:avLst/>
@@ -3406,8 +3406,8 @@
         </p:nvSpPr>
         <p:spPr>
           <a:xfrm>
-            <a:off x="914400" y="1645920"/>
-            <a:ext cx="2971800" cy="3291840"/>
+            <a:off x="868680" y="1463040"/>
+            <a:ext cx="2194560" cy="1188720"/>
           </a:xfrm>
           <a:prstGeom prst="rect">
             <a:avLst/>
@@ -3422,53 +3422,28 @@
           <a:p>
             <a:pPr>
               <a:spcAft>
-                <a:spcPts val="800"/>
+                <a:spcPts val="400"/>
               </a:spcAft>
-              <a:defRPr b="1" sz="1000">
+              <a:defRPr b="1" sz="1100">
                 <a:solidFill>
                   <a:srgbClr val="059669"/>
                 </a:solidFill>
               </a:defRPr>
             </a:pPr>
             <a:r>
-              <a:t>PHASE 1 (MONTHS 0-3)</a:t>
-            </a:r>
-          </a:p>
-          <a:p>
-            <a:pPr>
-              <a:spcAft>
-                <a:spcPts val="1000"/>
-              </a:spcAft>
-              <a:defRPr b="1" sz="1500">
+              <a:t>99.9% FASTER</a:t>
+            </a:r>
+          </a:p>
+          <a:p>
+            <a:pPr>
+              <a:defRPr b="1" sz="1300">
                 <a:solidFill>
                   <a:srgbClr val="0F172A"/>
                 </a:solidFill>
               </a:defRPr>
             </a:pPr>
             <a:r>
-              <a:t>High-Risk Pilot Deployment</a:t>
-            </a:r>
-          </a:p>
-          <a:p>
-            <a:pPr>
-              <a:defRPr sz="1050">
-                <a:solidFill>
-                  <a:srgbClr val="0F172A"/>
-                </a:solidFill>
-              </a:defRPr>
-            </a:pPr>
-            <a:r>
-              <a:t>• Deploy across 5 flood &amp; epidemic prone districts (Assam, Bihar, Maharashtra).</a:t>
-            </a:r>
-            <a:br/>
-            <a:br/>
-            <a:r>
-              <a:t>• Onboard 2,500 frontline ASHA/ANM workers with Indic voice assistant.</a:t>
-            </a:r>
-            <a:br/>
-            <a:br/>
-            <a:r>
-              <a:t>• Benchmark stockout reductions during active monsoon flood season.</a:t>
+              <a:t>24h Lag -&gt; 2.4s Ingestion</a:t>
             </a:r>
           </a:p>
         </p:txBody>
@@ -3481,14 +3456,14 @@
         </p:nvSpPr>
         <p:spPr>
           <a:xfrm>
-            <a:off x="4370832" y="1463040"/>
-            <a:ext cx="3337560" cy="3657600"/>
+            <a:off x="3456432" y="1371600"/>
+            <a:ext cx="2468880" cy="1371600"/>
           </a:xfrm>
           <a:prstGeom prst="roundRect">
             <a:avLst/>
           </a:prstGeom>
           <a:solidFill>
-            <a:srgbClr val="EFF6FF"/>
+            <a:srgbClr val="FEF2F2"/>
           </a:solidFill>
           <a:ln w="12700">
             <a:solidFill>
@@ -3526,8 +3501,8 @@
         </p:nvSpPr>
         <p:spPr>
           <a:xfrm>
-            <a:off x="4553712" y="1645920"/>
-            <a:ext cx="2971800" cy="3291840"/>
+            <a:off x="3593592" y="1463040"/>
+            <a:ext cx="2194560" cy="1188720"/>
           </a:xfrm>
           <a:prstGeom prst="rect">
             <a:avLst/>
@@ -3542,53 +3517,28 @@
           <a:p>
             <a:pPr>
               <a:spcAft>
-                <a:spcPts val="800"/>
+                <a:spcPts val="400"/>
               </a:spcAft>
-              <a:defRPr b="1" sz="1000">
-                <a:solidFill>
-                  <a:srgbClr val="1E40AF"/>
-                </a:solidFill>
-              </a:defRPr>
-            </a:pPr>
-            <a:r>
-              <a:t>PHASE 2 (MONTHS 3-9)</a:t>
-            </a:r>
-          </a:p>
-          <a:p>
-            <a:pPr>
-              <a:spcAft>
-                <a:spcPts val="1000"/>
-              </a:spcAft>
-              <a:defRPr b="1" sz="1500">
+              <a:defRPr b="1" sz="1100">
+                <a:solidFill>
+                  <a:srgbClr val="DC2626"/>
+                </a:solidFill>
+              </a:defRPr>
+            </a:pPr>
+            <a:r>
+              <a:t>88.4% STOCKOUT REDUCTION</a:t>
+            </a:r>
+          </a:p>
+          <a:p>
+            <a:pPr>
+              <a:defRPr b="1" sz="1300">
                 <a:solidFill>
                   <a:srgbClr val="0F172A"/>
                 </a:solidFill>
               </a:defRPr>
             </a:pPr>
             <a:r>
-              <a:t>Statewide Cluster Federated Rollout</a:t>
-            </a:r>
-          </a:p>
-          <a:p>
-            <a:pPr>
-              <a:defRPr sz="1050">
-                <a:solidFill>
-                  <a:srgbClr val="0F172A"/>
-                </a:solidFill>
-              </a:defRPr>
-            </a:pPr>
-            <a:r>
-              <a:t>• Expand to 4 regional state health directorates with active federated nodes.</a:t>
-            </a:r>
-            <a:br/>
-            <a:br/>
-            <a:r>
-              <a:t>• Connect district cold-chain logistics hubs to the automated redistribution engine.</a:t>
-            </a:r>
-            <a:br/>
-            <a:br/>
-            <a:r>
-              <a:t>• Integrate Ayushman Bharat Digital Mission (ABDM) facility registries.</a:t>
+              <a:t>7-Day Early Warnings</a:t>
             </a:r>
           </a:p>
         </p:txBody>
@@ -3601,14 +3551,14 @@
         </p:nvSpPr>
         <p:spPr>
           <a:xfrm>
-            <a:off x="8010144" y="1463040"/>
-            <a:ext cx="3337560" cy="3657600"/>
+            <a:off x="6181344" y="1371600"/>
+            <a:ext cx="2468880" cy="1371600"/>
           </a:xfrm>
           <a:prstGeom prst="roundRect">
             <a:avLst/>
           </a:prstGeom>
           <a:solidFill>
-            <a:srgbClr val="F8FAFC"/>
+            <a:srgbClr val="EFF6FF"/>
           </a:solidFill>
           <a:ln w="12700">
             <a:solidFill>
@@ -3646,8 +3596,8 @@
         </p:nvSpPr>
         <p:spPr>
           <a:xfrm>
-            <a:off x="8193024" y="1645920"/>
-            <a:ext cx="2971800" cy="3291840"/>
+            <a:off x="6318504" y="1463040"/>
+            <a:ext cx="2194560" cy="1188720"/>
           </a:xfrm>
           <a:prstGeom prst="rect">
             <a:avLst/>
@@ -3662,53 +3612,28 @@
           <a:p>
             <a:pPr>
               <a:spcAft>
-                <a:spcPts val="800"/>
+                <a:spcPts val="400"/>
               </a:spcAft>
-              <a:defRPr b="1" sz="1000">
-                <a:solidFill>
-                  <a:srgbClr val="D97706"/>
-                </a:solidFill>
-              </a:defRPr>
-            </a:pPr>
-            <a:r>
-              <a:t>PHASE 3 (MONTHS 9-18)</a:t>
-            </a:r>
-          </a:p>
-          <a:p>
-            <a:pPr>
-              <a:spcAft>
-                <a:spcPts val="1000"/>
-              </a:spcAft>
-              <a:defRPr b="1" sz="1500">
+              <a:defRPr b="1" sz="1100">
+                <a:solidFill>
+                  <a:srgbClr val="1E40AF"/>
+                </a:solidFill>
+              </a:defRPr>
+            </a:pPr>
+            <a:r>
+              <a:t>95% SHORTER DISPATCH TAT</a:t>
+            </a:r>
+          </a:p>
+          <a:p>
+            <a:pPr>
+              <a:defRPr b="1" sz="1300">
                 <a:solidFill>
                   <a:srgbClr val="0F172A"/>
                 </a:solidFill>
               </a:defRPr>
             </a:pPr>
             <a:r>
-              <a:t>Pan-India National Integration</a:t>
-            </a:r>
-          </a:p>
-          <a:p>
-            <a:pPr>
-              <a:defRPr sz="1050">
-                <a:solidFill>
-                  <a:srgbClr val="0F172A"/>
-                </a:solidFill>
-              </a:defRPr>
-            </a:pPr>
-            <a:r>
-              <a:t>• Full deployment across all 31,000+ PHCs and 150,000+ Sub-Centres.</a:t>
-            </a:r>
-            <a:br/>
-            <a:br/>
-            <a:r>
-              <a:t>• Universal sovereign federated predictive intelligence.</a:t>
-            </a:r>
-            <a:br/>
-            <a:br/>
-            <a:r>
-              <a:t>• Real-time national resilience safeguarding all 1.4 billion citizens.</a:t>
+              <a:t>5 Days -&gt; &lt; 4 Hours</a:t>
             </a:r>
           </a:p>
         </p:txBody>
@@ -3721,18 +3646,18 @@
         </p:nvSpPr>
         <p:spPr>
           <a:xfrm>
-            <a:off x="731520" y="5349240"/>
-            <a:ext cx="10728655" cy="914400"/>
+            <a:off x="8906256" y="1371600"/>
+            <a:ext cx="2468880" cy="1371600"/>
           </a:xfrm>
           <a:prstGeom prst="roundRect">
             <a:avLst/>
           </a:prstGeom>
           <a:solidFill>
-            <a:srgbClr val="ECFDF5"/>
+            <a:srgbClr val="FFFBEB"/>
           </a:solidFill>
           <a:ln w="12700">
             <a:solidFill>
-              <a:srgbClr val="A7F3D0"/>
+              <a:srgbClr val="E2E8F0"/>
             </a:solidFill>
           </a:ln>
         </p:spPr>
@@ -3766,8 +3691,457 @@
         </p:nvSpPr>
         <p:spPr>
           <a:xfrm>
-            <a:off x="914400" y="5440680"/>
-            <a:ext cx="10362895" cy="731520"/>
+            <a:off x="9043416" y="1463040"/>
+            <a:ext cx="2194560" cy="1188720"/>
+          </a:xfrm>
+          <a:prstGeom prst="rect">
+            <a:avLst/>
+          </a:prstGeom>
+          <a:noFill/>
+        </p:spPr>
+        <p:txBody>
+          <a:bodyPr wrap="square">
+            <a:spAutoFit/>
+          </a:bodyPr>
+          <a:lstStyle/>
+          <a:p>
+            <a:pPr>
+              <a:spcAft>
+                <a:spcPts val="400"/>
+              </a:spcAft>
+              <a:defRPr b="1" sz="1100">
+                <a:solidFill>
+                  <a:srgbClr val="D97706"/>
+                </a:solidFill>
+              </a:defRPr>
+            </a:pPr>
+            <a:r>
+              <a:t>2.5 HRS SAVED / DAY</a:t>
+            </a:r>
+          </a:p>
+          <a:p>
+            <a:pPr>
+              <a:defRPr b="1" sz="1300">
+                <a:solidFill>
+                  <a:srgbClr val="0F172A"/>
+                </a:solidFill>
+              </a:defRPr>
+            </a:pPr>
+            <a:r>
+              <a:t>Zero Manual Paperwork</a:t>
+            </a:r>
+          </a:p>
+        </p:txBody>
+      </p:sp>
+      <p:sp>
+        <p:nvSpPr>
+          <p:cNvPr id="11" name="Rounded Rectangle 10"/>
+          <p:cNvSpPr/>
+          <p:nvPr/>
+        </p:nvSpPr>
+        <p:spPr>
+          <a:xfrm>
+            <a:off x="731520" y="2926080"/>
+            <a:ext cx="3337560" cy="2103120"/>
+          </a:xfrm>
+          <a:prstGeom prst="roundRect">
+            <a:avLst/>
+          </a:prstGeom>
+          <a:solidFill>
+            <a:srgbClr val="F8FAFC"/>
+          </a:solidFill>
+          <a:ln w="12700">
+            <a:solidFill>
+              <a:srgbClr val="E2E8F0"/>
+            </a:solidFill>
+          </a:ln>
+        </p:spPr>
+        <p:style>
+          <a:lnRef idx="1">
+            <a:schemeClr val="accent1"/>
+          </a:lnRef>
+          <a:fillRef idx="3">
+            <a:schemeClr val="accent1"/>
+          </a:fillRef>
+          <a:effectRef idx="2">
+            <a:schemeClr val="accent1"/>
+          </a:effectRef>
+          <a:fontRef idx="minor">
+            <a:schemeClr val="lt1"/>
+          </a:fontRef>
+        </p:style>
+        <p:txBody>
+          <a:bodyPr rtlCol="0" anchor="ctr"/>
+          <a:lstStyle/>
+          <a:p>
+            <a:pPr algn="ctr"/>
+          </a:p>
+        </p:txBody>
+      </p:sp>
+      <p:sp>
+        <p:nvSpPr>
+          <p:cNvPr id="12" name="TextBox 11"/>
+          <p:cNvSpPr txBox="1"/>
+          <p:nvPr/>
+        </p:nvSpPr>
+        <p:spPr>
+          <a:xfrm>
+            <a:off x="896112" y="3017520"/>
+            <a:ext cx="3008376" cy="1920240"/>
+          </a:xfrm>
+          <a:prstGeom prst="rect">
+            <a:avLst/>
+          </a:prstGeom>
+          <a:noFill/>
+        </p:spPr>
+        <p:txBody>
+          <a:bodyPr wrap="square">
+            <a:spAutoFit/>
+          </a:bodyPr>
+          <a:lstStyle/>
+          <a:p>
+            <a:pPr>
+              <a:spcAft>
+                <a:spcPts val="400"/>
+              </a:spcAft>
+              <a:defRPr b="1" sz="950">
+                <a:solidFill>
+                  <a:srgbClr val="059669"/>
+                </a:solidFill>
+              </a:defRPr>
+            </a:pPr>
+            <a:r>
+              <a:t>PHASE 1 (MONTHS 0-3)</a:t>
+            </a:r>
+          </a:p>
+          <a:p>
+            <a:pPr>
+              <a:spcAft>
+                <a:spcPts val="600"/>
+              </a:spcAft>
+              <a:defRPr b="1" sz="1200">
+                <a:solidFill>
+                  <a:srgbClr val="0F172A"/>
+                </a:solidFill>
+              </a:defRPr>
+            </a:pPr>
+            <a:r>
+              <a:t>High-Risk Pilot Deployment</a:t>
+            </a:r>
+          </a:p>
+          <a:p>
+            <a:pPr>
+              <a:defRPr sz="950">
+                <a:solidFill>
+                  <a:srgbClr val="0F172A"/>
+                </a:solidFill>
+              </a:defRPr>
+            </a:pPr>
+            <a:r>
+              <a:t>• Deploy across 5 flood &amp; epidemic prone districts.</a:t>
+            </a:r>
+            <a:br/>
+            <a:r>
+              <a:t>• Onboard 2,500 frontline ASHA/ANM workers with Indic voice assistant.</a:t>
+            </a:r>
+            <a:br/>
+            <a:r>
+              <a:t>• Benchmark stockout reductions during active monsoon flood season.</a:t>
+            </a:r>
+          </a:p>
+        </p:txBody>
+      </p:sp>
+      <p:sp>
+        <p:nvSpPr>
+          <p:cNvPr id="13" name="Rounded Rectangle 12"/>
+          <p:cNvSpPr/>
+          <p:nvPr/>
+        </p:nvSpPr>
+        <p:spPr>
+          <a:xfrm>
+            <a:off x="4370832" y="2926080"/>
+            <a:ext cx="3337560" cy="2103120"/>
+          </a:xfrm>
+          <a:prstGeom prst="roundRect">
+            <a:avLst/>
+          </a:prstGeom>
+          <a:solidFill>
+            <a:srgbClr val="F8FAFC"/>
+          </a:solidFill>
+          <a:ln w="12700">
+            <a:solidFill>
+              <a:srgbClr val="E2E8F0"/>
+            </a:solidFill>
+          </a:ln>
+        </p:spPr>
+        <p:style>
+          <a:lnRef idx="1">
+            <a:schemeClr val="accent1"/>
+          </a:lnRef>
+          <a:fillRef idx="3">
+            <a:schemeClr val="accent1"/>
+          </a:fillRef>
+          <a:effectRef idx="2">
+            <a:schemeClr val="accent1"/>
+          </a:effectRef>
+          <a:fontRef idx="minor">
+            <a:schemeClr val="lt1"/>
+          </a:fontRef>
+        </p:style>
+        <p:txBody>
+          <a:bodyPr rtlCol="0" anchor="ctr"/>
+          <a:lstStyle/>
+          <a:p>
+            <a:pPr algn="ctr"/>
+          </a:p>
+        </p:txBody>
+      </p:sp>
+      <p:sp>
+        <p:nvSpPr>
+          <p:cNvPr id="14" name="TextBox 13"/>
+          <p:cNvSpPr txBox="1"/>
+          <p:nvPr/>
+        </p:nvSpPr>
+        <p:spPr>
+          <a:xfrm>
+            <a:off x="4535424" y="3017520"/>
+            <a:ext cx="3008376" cy="1920240"/>
+          </a:xfrm>
+          <a:prstGeom prst="rect">
+            <a:avLst/>
+          </a:prstGeom>
+          <a:noFill/>
+        </p:spPr>
+        <p:txBody>
+          <a:bodyPr wrap="square">
+            <a:spAutoFit/>
+          </a:bodyPr>
+          <a:lstStyle/>
+          <a:p>
+            <a:pPr>
+              <a:spcAft>
+                <a:spcPts val="400"/>
+              </a:spcAft>
+              <a:defRPr b="1" sz="950">
+                <a:solidFill>
+                  <a:srgbClr val="1E40AF"/>
+                </a:solidFill>
+              </a:defRPr>
+            </a:pPr>
+            <a:r>
+              <a:t>PHASE 2 (MONTHS 3-9)</a:t>
+            </a:r>
+          </a:p>
+          <a:p>
+            <a:pPr>
+              <a:spcAft>
+                <a:spcPts val="600"/>
+              </a:spcAft>
+              <a:defRPr b="1" sz="1200">
+                <a:solidFill>
+                  <a:srgbClr val="0F172A"/>
+                </a:solidFill>
+              </a:defRPr>
+            </a:pPr>
+            <a:r>
+              <a:t>Statewide Cluster Federated Rollout</a:t>
+            </a:r>
+          </a:p>
+          <a:p>
+            <a:pPr>
+              <a:defRPr sz="950">
+                <a:solidFill>
+                  <a:srgbClr val="0F172A"/>
+                </a:solidFill>
+              </a:defRPr>
+            </a:pPr>
+            <a:r>
+              <a:t>• Expand to 4 regional state health directorates with active federated nodes.</a:t>
+            </a:r>
+            <a:br/>
+            <a:r>
+              <a:t>• Connect district cold-chain logistics hubs to redistribution engine.</a:t>
+            </a:r>
+            <a:br/>
+            <a:r>
+              <a:t>• Integrate Ayushman Bharat Digital Mission (ABDM) registries.</a:t>
+            </a:r>
+          </a:p>
+        </p:txBody>
+      </p:sp>
+      <p:sp>
+        <p:nvSpPr>
+          <p:cNvPr id="15" name="Rounded Rectangle 14"/>
+          <p:cNvSpPr/>
+          <p:nvPr/>
+        </p:nvSpPr>
+        <p:spPr>
+          <a:xfrm>
+            <a:off x="8010144" y="2926080"/>
+            <a:ext cx="3337560" cy="2103120"/>
+          </a:xfrm>
+          <a:prstGeom prst="roundRect">
+            <a:avLst/>
+          </a:prstGeom>
+          <a:solidFill>
+            <a:srgbClr val="F8FAFC"/>
+          </a:solidFill>
+          <a:ln w="12700">
+            <a:solidFill>
+              <a:srgbClr val="E2E8F0"/>
+            </a:solidFill>
+          </a:ln>
+        </p:spPr>
+        <p:style>
+          <a:lnRef idx="1">
+            <a:schemeClr val="accent1"/>
+          </a:lnRef>
+          <a:fillRef idx="3">
+            <a:schemeClr val="accent1"/>
+          </a:fillRef>
+          <a:effectRef idx="2">
+            <a:schemeClr val="accent1"/>
+          </a:effectRef>
+          <a:fontRef idx="minor">
+            <a:schemeClr val="lt1"/>
+          </a:fontRef>
+        </p:style>
+        <p:txBody>
+          <a:bodyPr rtlCol="0" anchor="ctr"/>
+          <a:lstStyle/>
+          <a:p>
+            <a:pPr algn="ctr"/>
+          </a:p>
+        </p:txBody>
+      </p:sp>
+      <p:sp>
+        <p:nvSpPr>
+          <p:cNvPr id="16" name="TextBox 15"/>
+          <p:cNvSpPr txBox="1"/>
+          <p:nvPr/>
+        </p:nvSpPr>
+        <p:spPr>
+          <a:xfrm>
+            <a:off x="8174736" y="3017520"/>
+            <a:ext cx="3008376" cy="1920240"/>
+          </a:xfrm>
+          <a:prstGeom prst="rect">
+            <a:avLst/>
+          </a:prstGeom>
+          <a:noFill/>
+        </p:spPr>
+        <p:txBody>
+          <a:bodyPr wrap="square">
+            <a:spAutoFit/>
+          </a:bodyPr>
+          <a:lstStyle/>
+          <a:p>
+            <a:pPr>
+              <a:spcAft>
+                <a:spcPts val="400"/>
+              </a:spcAft>
+              <a:defRPr b="1" sz="950">
+                <a:solidFill>
+                  <a:srgbClr val="D97706"/>
+                </a:solidFill>
+              </a:defRPr>
+            </a:pPr>
+            <a:r>
+              <a:t>PHASE 3 (MONTHS 9-18)</a:t>
+            </a:r>
+          </a:p>
+          <a:p>
+            <a:pPr>
+              <a:spcAft>
+                <a:spcPts val="600"/>
+              </a:spcAft>
+              <a:defRPr b="1" sz="1200">
+                <a:solidFill>
+                  <a:srgbClr val="0F172A"/>
+                </a:solidFill>
+              </a:defRPr>
+            </a:pPr>
+            <a:r>
+              <a:t>Pan-India National Integration</a:t>
+            </a:r>
+          </a:p>
+          <a:p>
+            <a:pPr>
+              <a:defRPr sz="950">
+                <a:solidFill>
+                  <a:srgbClr val="0F172A"/>
+                </a:solidFill>
+              </a:defRPr>
+            </a:pPr>
+            <a:r>
+              <a:t>• Full deployment across all 31,000+ PHCs and 150,000+ Sub-Centres.</a:t>
+            </a:r>
+            <a:br/>
+            <a:r>
+              <a:t>• Universal sovereign federated predictive intelligence.</a:t>
+            </a:r>
+            <a:br/>
+            <a:r>
+              <a:t>• Real-time national resilience safeguarding all 1.4 billion citizens.</a:t>
+            </a:r>
+          </a:p>
+        </p:txBody>
+      </p:sp>
+      <p:sp>
+        <p:nvSpPr>
+          <p:cNvPr id="17" name="Rounded Rectangle 16"/>
+          <p:cNvSpPr/>
+          <p:nvPr/>
+        </p:nvSpPr>
+        <p:spPr>
+          <a:xfrm>
+            <a:off x="731520" y="5257800"/>
+            <a:ext cx="10728655" cy="1005840"/>
+          </a:xfrm>
+          <a:prstGeom prst="roundRect">
+            <a:avLst/>
+          </a:prstGeom>
+          <a:solidFill>
+            <a:srgbClr val="ECFDF5"/>
+          </a:solidFill>
+          <a:ln w="12700">
+            <a:solidFill>
+              <a:srgbClr val="A7F3D0"/>
+            </a:solidFill>
+          </a:ln>
+        </p:spPr>
+        <p:style>
+          <a:lnRef idx="1">
+            <a:schemeClr val="accent1"/>
+          </a:lnRef>
+          <a:fillRef idx="3">
+            <a:schemeClr val="accent1"/>
+          </a:fillRef>
+          <a:effectRef idx="2">
+            <a:schemeClr val="accent1"/>
+          </a:effectRef>
+          <a:fontRef idx="minor">
+            <a:schemeClr val="lt1"/>
+          </a:fontRef>
+        </p:style>
+        <p:txBody>
+          <a:bodyPr rtlCol="0" anchor="ctr"/>
+          <a:lstStyle/>
+          <a:p>
+            <a:pPr algn="ctr"/>
+          </a:p>
+        </p:txBody>
+      </p:sp>
+      <p:sp>
+        <p:nvSpPr>
+          <p:cNvPr id="18" name="TextBox 17"/>
+          <p:cNvSpPr txBox="1"/>
+          <p:nvPr/>
+        </p:nvSpPr>
+        <p:spPr>
+          <a:xfrm>
+            <a:off x="914400" y="5349240"/>
+            <a:ext cx="10362895" cy="822960"/>
           </a:xfrm>
           <a:prstGeom prst="rect">
             <a:avLst/>
@@ -3791,7 +4165,7 @@
               </a:defRPr>
             </a:pPr>
             <a:r>
-              <a:t>THE SANJEEVINI NATIONAL VISION:</a:t>
+              <a:t>THE SANJEEVINI NATIONAL COMMITMENT:</a:t>
             </a:r>
           </a:p>
           <a:p>
@@ -3810,7 +4184,7 @@
       </p:sp>
       <p:sp>
         <p:nvSpPr>
-          <p:cNvPr id="11" name="TextBox 10"/>
+          <p:cNvPr id="19" name="TextBox 18"/>
           <p:cNvSpPr txBox="1"/>
           <p:nvPr/>
         </p:nvSpPr>
@@ -3838,7 +4212,7 @@
               </a:defRPr>
             </a:pPr>
             <a:r>
-              <a:t>संजीविनी (Sanjeevini) | National Health Resource &amp; Supply Chain Resilience Platform   •   Slide 10 of 10</a:t>
+              <a:t>Sanjeevini | National Health Resource &amp; Supply Chain Resilience Platform   •   Slide 10 of 10</a:t>
             </a:r>
           </a:p>
         </p:txBody>
@@ -4286,7 +4660,7 @@
               </a:defRPr>
             </a:pPr>
             <a:r>
-              <a:t>संजीविनी (Sanjeevini) | National Health Resource &amp; Supply Chain Resilience Platform   •   Slide 2 of 10</a:t>
+              <a:t>Sanjeevini | National Health Resource &amp; Supply Chain Resilience Platform   •   Slide 2 of 10</a:t>
             </a:r>
           </a:p>
         </p:txBody>
@@ -4342,7 +4716,7 @@
               </a:defRPr>
             </a:pPr>
             <a:r>
-              <a:t>HOLISTIC PLATFORM ARCHITECTURE</a:t>
+              <a:t>HOLISTIC PLATFORM STRATEGY</a:t>
             </a:r>
           </a:p>
           <a:p>
@@ -4881,7 +5255,7 @@
               </a:defRPr>
             </a:pPr>
             <a:r>
-              <a:t>संजीविनी (Sanjeevini) | National Health Resource &amp; Supply Chain Resilience Platform   •   Slide 3 of 10</a:t>
+              <a:t>Sanjeevini | National Health Resource &amp; Supply Chain Resilience Platform   •   Slide 3 of 10</a:t>
             </a:r>
           </a:p>
         </p:txBody>
@@ -4937,7 +5311,7 @@
               </a:defRPr>
             </a:pPr>
             <a:r>
-              <a:t>REAL-TIME OPERATIONAL INTELLIGENCE</a:t>
+              <a:t>5-TIER CLOUD &amp; EDGE INFRASTRUCTURE</a:t>
             </a:r>
           </a:p>
           <a:p>
@@ -4949,21 +5323,66 @@
               </a:defRPr>
             </a:pPr>
             <a:r>
-              <a:t>National Command Center &amp; High-Precision CARTO GIS Surveillance</a:t>
-            </a:r>
-          </a:p>
-        </p:txBody>
-      </p:sp>
-      <p:sp>
-        <p:nvSpPr>
-          <p:cNvPr id="3" name="TextBox 2"/>
+              <a:t>System Architecture: End-to-End Enterprise Design</a:t>
+            </a:r>
+          </a:p>
+        </p:txBody>
+      </p:sp>
+      <p:sp>
+        <p:nvSpPr>
+          <p:cNvPr id="3" name="Rounded Rectangle 2"/>
+          <p:cNvSpPr/>
+          <p:nvPr/>
+        </p:nvSpPr>
+        <p:spPr>
+          <a:xfrm>
+            <a:off x="731520" y="1417320"/>
+            <a:ext cx="10728655" cy="822960"/>
+          </a:xfrm>
+          <a:prstGeom prst="roundRect">
+            <a:avLst/>
+          </a:prstGeom>
+          <a:solidFill>
+            <a:srgbClr val="ECFDF5"/>
+          </a:solidFill>
+          <a:ln w="12700">
+            <a:solidFill>
+              <a:srgbClr val="E2E8F0"/>
+            </a:solidFill>
+          </a:ln>
+        </p:spPr>
+        <p:style>
+          <a:lnRef idx="1">
+            <a:schemeClr val="accent1"/>
+          </a:lnRef>
+          <a:fillRef idx="3">
+            <a:schemeClr val="accent1"/>
+          </a:fillRef>
+          <a:effectRef idx="2">
+            <a:schemeClr val="accent1"/>
+          </a:effectRef>
+          <a:fontRef idx="minor">
+            <a:schemeClr val="lt1"/>
+          </a:fontRef>
+        </p:style>
+        <p:txBody>
+          <a:bodyPr rtlCol="0" anchor="ctr"/>
+          <a:lstStyle/>
+          <a:p>
+            <a:pPr algn="ctr"/>
+          </a:p>
+        </p:txBody>
+      </p:sp>
+      <p:sp>
+        <p:nvSpPr>
+          <p:cNvPr id="4" name="TextBox 3"/>
           <p:cNvSpPr txBox="1"/>
           <p:nvPr/>
         </p:nvSpPr>
         <p:spPr>
           <a:xfrm>
-            <a:off x="731520" y="1463040"/>
-            <a:ext cx="4206240" cy="4389120"/>
+            <a:off x="914400" y="1508760"/>
+            <a:ext cx="10362895" cy="640080"/>
           </a:xfrm>
           <a:prstGeom prst="rect">
             <a:avLst/>
@@ -4978,23 +5397,115 @@
           <a:p>
             <a:pPr>
               <a:spcAft>
-                <a:spcPts val="1200"/>
+                <a:spcPts val="200"/>
               </a:spcAft>
-              <a:defRPr b="1" sz="1700">
+              <a:defRPr b="1" sz="1100">
+                <a:solidFill>
+                  <a:srgbClr val="059669"/>
+                </a:solidFill>
+              </a:defRPr>
+            </a:pPr>
+            <a:r>
+              <a:t>1. CLIENTS &amp; FRONTLINE CADRES</a:t>
+            </a:r>
+          </a:p>
+          <a:p>
+            <a:pPr>
+              <a:defRPr sz="1100">
                 <a:solidFill>
                   <a:srgbClr val="0F172A"/>
                 </a:solidFill>
               </a:defRPr>
             </a:pPr>
             <a:r>
-              <a:t>Macroscopic Visibility with Micro-Targeting</a:t>
-            </a:r>
-          </a:p>
+              <a:t>ASHA / ANM Mobile PWA &amp; Voice  •  PHC Medical Officer Ground Console  •  District Health Officer Hub  •  National MoHFW Command Deck</a:t>
+            </a:r>
+          </a:p>
+        </p:txBody>
+      </p:sp>
+      <p:sp>
+        <p:nvSpPr>
+          <p:cNvPr id="5" name="Rounded Rectangle 4"/>
+          <p:cNvSpPr/>
+          <p:nvPr/>
+        </p:nvSpPr>
+        <p:spPr>
+          <a:xfrm>
+            <a:off x="731520" y="2377440"/>
+            <a:ext cx="10728655" cy="822960"/>
+          </a:xfrm>
+          <a:prstGeom prst="roundRect">
+            <a:avLst/>
+          </a:prstGeom>
+          <a:solidFill>
+            <a:srgbClr val="EFF6FF"/>
+          </a:solidFill>
+          <a:ln w="12700">
+            <a:solidFill>
+              <a:srgbClr val="E2E8F0"/>
+            </a:solidFill>
+          </a:ln>
+        </p:spPr>
+        <p:style>
+          <a:lnRef idx="1">
+            <a:schemeClr val="accent1"/>
+          </a:lnRef>
+          <a:fillRef idx="3">
+            <a:schemeClr val="accent1"/>
+          </a:fillRef>
+          <a:effectRef idx="2">
+            <a:schemeClr val="accent1"/>
+          </a:effectRef>
+          <a:fontRef idx="minor">
+            <a:schemeClr val="lt1"/>
+          </a:fontRef>
+        </p:style>
+        <p:txBody>
+          <a:bodyPr rtlCol="0" anchor="ctr"/>
+          <a:lstStyle/>
+          <a:p>
+            <a:pPr algn="ctr"/>
+          </a:p>
+        </p:txBody>
+      </p:sp>
+      <p:sp>
+        <p:nvSpPr>
+          <p:cNvPr id="6" name="TextBox 5"/>
+          <p:cNvSpPr txBox="1"/>
+          <p:nvPr/>
+        </p:nvSpPr>
+        <p:spPr>
+          <a:xfrm>
+            <a:off x="914400" y="2468880"/>
+            <a:ext cx="10362895" cy="640080"/>
+          </a:xfrm>
+          <a:prstGeom prst="rect">
+            <a:avLst/>
+          </a:prstGeom>
+          <a:noFill/>
+        </p:spPr>
+        <p:txBody>
+          <a:bodyPr wrap="square">
+            <a:spAutoFit/>
+          </a:bodyPr>
+          <a:lstStyle/>
           <a:p>
             <a:pPr>
               <a:spcAft>
-                <a:spcPts val="1400"/>
+                <a:spcPts val="200"/>
               </a:spcAft>
+              <a:defRPr b="1" sz="1100">
+                <a:solidFill>
+                  <a:srgbClr val="1E40AF"/>
+                </a:solidFill>
+              </a:defRPr>
+            </a:pPr>
+            <a:r>
+              <a:t>2. PRESENTATION &amp; GIS LAYER</a:t>
+            </a:r>
+          </a:p>
+          <a:p>
+            <a:pPr>
               <a:defRPr sz="1100">
                 <a:solidFill>
                   <a:srgbClr val="0F172A"/>
@@ -5002,84 +5513,299 @@
               </a:defRPr>
             </a:pPr>
             <a:r>
-              <a:t>• Live Monitoring Across 31,000+ PHCs: National command dashboard aggregates medicine inventories, active emergency beds, and doctor attendance continuously.</a:t>
-            </a:r>
-            <a:br/>
-            <a:br/>
-            <a:r>
-              <a:t>• Epidemic Heat Surveillance: Real-time geofenced cluster zones alert commanders to monsoon waterborne surges (e.g. Cachar flood zone) and vector outbreaks (e.g. Pune dengue surge).</a:t>
-            </a:r>
-            <a:br/>
-            <a:br/>
-            <a:r>
-              <a:t>• Multi-Tier Governance: Seamless switching between MoHFW National Super-Admin, State Health Directorates, District Health Officers (DHOs), and Ground PHCs.</a:t>
-            </a:r>
-          </a:p>
-          <a:p>
-            <a:pPr>
-              <a:defRPr sz="950" b="1">
+              <a:t>React 18 TypeScript Vite SPA  •  CARTO Positron &amp; Leaflet GIS Engine  •  22-Language Audio Processor  •  Camera / OCR Canvas Extractor</a:t>
+            </a:r>
+          </a:p>
+        </p:txBody>
+      </p:sp>
+      <p:sp>
+        <p:nvSpPr>
+          <p:cNvPr id="7" name="Rounded Rectangle 6"/>
+          <p:cNvSpPr/>
+          <p:nvPr/>
+        </p:nvSpPr>
+        <p:spPr>
+          <a:xfrm>
+            <a:off x="731520" y="3337560"/>
+            <a:ext cx="10728655" cy="822960"/>
+          </a:xfrm>
+          <a:prstGeom prst="roundRect">
+            <a:avLst/>
+          </a:prstGeom>
+          <a:solidFill>
+            <a:srgbClr val="F8FAFC"/>
+          </a:solidFill>
+          <a:ln w="12700">
+            <a:solidFill>
+              <a:srgbClr val="E2E8F0"/>
+            </a:solidFill>
+          </a:ln>
+        </p:spPr>
+        <p:style>
+          <a:lnRef idx="1">
+            <a:schemeClr val="accent1"/>
+          </a:lnRef>
+          <a:fillRef idx="3">
+            <a:schemeClr val="accent1"/>
+          </a:fillRef>
+          <a:effectRef idx="2">
+            <a:schemeClr val="accent1"/>
+          </a:effectRef>
+          <a:fontRef idx="minor">
+            <a:schemeClr val="lt1"/>
+          </a:fontRef>
+        </p:style>
+        <p:txBody>
+          <a:bodyPr rtlCol="0" anchor="ctr"/>
+          <a:lstStyle/>
+          <a:p>
+            <a:pPr algn="ctr"/>
+          </a:p>
+        </p:txBody>
+      </p:sp>
+      <p:sp>
+        <p:nvSpPr>
+          <p:cNvPr id="8" name="TextBox 7"/>
+          <p:cNvSpPr txBox="1"/>
+          <p:nvPr/>
+        </p:nvSpPr>
+        <p:spPr>
+          <a:xfrm>
+            <a:off x="914400" y="3429000"/>
+            <a:ext cx="10362895" cy="640080"/>
+          </a:xfrm>
+          <a:prstGeom prst="rect">
+            <a:avLst/>
+          </a:prstGeom>
+          <a:noFill/>
+        </p:spPr>
+        <p:txBody>
+          <a:bodyPr wrap="square">
+            <a:spAutoFit/>
+          </a:bodyPr>
+          <a:lstStyle/>
+          <a:p>
+            <a:pPr>
+              <a:spcAft>
+                <a:spcPts val="200"/>
+              </a:spcAft>
+              <a:defRPr b="1" sz="1100">
+                <a:solidFill>
+                  <a:srgbClr val="0F172A"/>
+                </a:solidFill>
+              </a:defRPr>
+            </a:pPr>
+            <a:r>
+              <a:t>3. CORE API &amp; BUSINESS LOGIC</a:t>
+            </a:r>
+          </a:p>
+          <a:p>
+            <a:pPr>
+              <a:defRPr sz="1100">
+                <a:solidFill>
+                  <a:srgbClr val="0F172A"/>
+                </a:solidFill>
+              </a:defRPr>
+            </a:pPr>
+            <a:r>
+              <a:t>FastAPI Core Services  •  Epidemiological Demand Engine  •  Cost-Distance-Expiry Matching  •  FedAvg Multi-State Coordinator  •  Gemini OCR Pipeline</a:t>
+            </a:r>
+          </a:p>
+        </p:txBody>
+      </p:sp>
+      <p:sp>
+        <p:nvSpPr>
+          <p:cNvPr id="9" name="Rounded Rectangle 8"/>
+          <p:cNvSpPr/>
+          <p:nvPr/>
+        </p:nvSpPr>
+        <p:spPr>
+          <a:xfrm>
+            <a:off x="731520" y="4297680"/>
+            <a:ext cx="10728655" cy="822960"/>
+          </a:xfrm>
+          <a:prstGeom prst="roundRect">
+            <a:avLst/>
+          </a:prstGeom>
+          <a:solidFill>
+            <a:srgbClr val="ECFDF5"/>
+          </a:solidFill>
+          <a:ln w="12700">
+            <a:solidFill>
+              <a:srgbClr val="E2E8F0"/>
+            </a:solidFill>
+          </a:ln>
+        </p:spPr>
+        <p:style>
+          <a:lnRef idx="1">
+            <a:schemeClr val="accent1"/>
+          </a:lnRef>
+          <a:fillRef idx="3">
+            <a:schemeClr val="accent1"/>
+          </a:fillRef>
+          <a:effectRef idx="2">
+            <a:schemeClr val="accent1"/>
+          </a:effectRef>
+          <a:fontRef idx="minor">
+            <a:schemeClr val="lt1"/>
+          </a:fontRef>
+        </p:style>
+        <p:txBody>
+          <a:bodyPr rtlCol="0" anchor="ctr"/>
+          <a:lstStyle/>
+          <a:p>
+            <a:pPr algn="ctr"/>
+          </a:p>
+        </p:txBody>
+      </p:sp>
+      <p:sp>
+        <p:nvSpPr>
+          <p:cNvPr id="10" name="TextBox 9"/>
+          <p:cNvSpPr txBox="1"/>
+          <p:nvPr/>
+        </p:nvSpPr>
+        <p:spPr>
+          <a:xfrm>
+            <a:off x="914400" y="4389120"/>
+            <a:ext cx="10362895" cy="640080"/>
+          </a:xfrm>
+          <a:prstGeom prst="rect">
+            <a:avLst/>
+          </a:prstGeom>
+          <a:noFill/>
+        </p:spPr>
+        <p:txBody>
+          <a:bodyPr wrap="square">
+            <a:spAutoFit/>
+          </a:bodyPr>
+          <a:lstStyle/>
+          <a:p>
+            <a:pPr>
+              <a:spcAft>
+                <a:spcPts val="200"/>
+              </a:spcAft>
+              <a:defRPr b="1" sz="1100">
                 <a:solidFill>
                   <a:srgbClr val="059669"/>
                 </a:solidFill>
               </a:defRPr>
             </a:pPr>
             <a:r>
-              <a:t>Layer Support: CARTO Positron (High-Legibility Light Mode), CARTO Voyager, CARTO Dark Matter, OpenStreetMap, and Google Maps.</a:t>
-            </a:r>
-          </a:p>
-        </p:txBody>
-      </p:sp>
-      <p:pic>
-        <p:nvPicPr>
-          <p:cNvPr id="4" name="Picture 3" descr="national_command.png"/>
-          <p:cNvPicPr>
-            <a:picLocks noChangeAspect="1"/>
-          </p:cNvPicPr>
-          <p:nvPr/>
-        </p:nvPicPr>
-        <p:blipFill>
-          <a:blip r:embed="rId2"/>
-          <a:stretch>
-            <a:fillRect/>
-          </a:stretch>
-        </p:blipFill>
-        <p:spPr>
-          <a:xfrm>
-            <a:off x="5120640" y="1371600"/>
-            <a:ext cx="6309360" cy="3549015"/>
+              <a:t>4. AI &amp; GOOGLE CLOUD SUITE</a:t>
+            </a:r>
+          </a:p>
+          <a:p>
+            <a:pPr>
+              <a:defRPr sz="1100">
+                <a:solidFill>
+                  <a:srgbClr val="0F172A"/>
+                </a:solidFill>
+              </a:defRPr>
+            </a:pPr>
+            <a:r>
+              <a:t>Google Gemini 1.5 Flash  •  Vertex AI Time-Series Forecaster  •  Cloud Speech-to-Text &amp; TTS  •  Google Translation  •  BigQuery (HMIS/IDSP Bridge)</a:t>
+            </a:r>
+          </a:p>
+        </p:txBody>
+      </p:sp>
+      <p:sp>
+        <p:nvSpPr>
+          <p:cNvPr id="11" name="Rounded Rectangle 10"/>
+          <p:cNvSpPr/>
+          <p:nvPr/>
+        </p:nvSpPr>
+        <p:spPr>
+          <a:xfrm>
+            <a:off x="731520" y="5257800"/>
+            <a:ext cx="10728655" cy="822960"/>
+          </a:xfrm>
+          <a:prstGeom prst="roundRect">
+            <a:avLst/>
+          </a:prstGeom>
+          <a:solidFill>
+            <a:srgbClr val="FFFBEB"/>
+          </a:solidFill>
+          <a:ln w="12700">
+            <a:solidFill>
+              <a:srgbClr val="E2E8F0"/>
+            </a:solidFill>
+          </a:ln>
+        </p:spPr>
+        <p:style>
+          <a:lnRef idx="1">
+            <a:schemeClr val="accent1"/>
+          </a:lnRef>
+          <a:fillRef idx="3">
+            <a:schemeClr val="accent1"/>
+          </a:fillRef>
+          <a:effectRef idx="2">
+            <a:schemeClr val="accent1"/>
+          </a:effectRef>
+          <a:fontRef idx="minor">
+            <a:schemeClr val="lt1"/>
+          </a:fontRef>
+        </p:style>
+        <p:txBody>
+          <a:bodyPr rtlCol="0" anchor="ctr"/>
+          <a:lstStyle/>
+          <a:p>
+            <a:pPr algn="ctr"/>
+          </a:p>
+        </p:txBody>
+      </p:sp>
+      <p:sp>
+        <p:nvSpPr>
+          <p:cNvPr id="12" name="TextBox 11"/>
+          <p:cNvSpPr txBox="1"/>
+          <p:nvPr/>
+        </p:nvSpPr>
+        <p:spPr>
+          <a:xfrm>
+            <a:off x="914400" y="5349240"/>
+            <a:ext cx="10362895" cy="640080"/>
           </a:xfrm>
           <a:prstGeom prst="rect">
             <a:avLst/>
           </a:prstGeom>
-        </p:spPr>
-      </p:pic>
-      <p:pic>
-        <p:nvPicPr>
-          <p:cNvPr id="5" name="Picture 4" descr="live_map.png"/>
-          <p:cNvPicPr>
-            <a:picLocks noChangeAspect="1"/>
-          </p:cNvPicPr>
-          <p:nvPr/>
-        </p:nvPicPr>
-        <p:blipFill>
-          <a:blip r:embed="rId3"/>
-          <a:stretch>
-            <a:fillRect/>
-          </a:stretch>
-        </p:blipFill>
-        <p:spPr>
-          <a:xfrm>
-            <a:off x="5120640" y="3840480"/>
-            <a:ext cx="6309360" cy="3549015"/>
-          </a:xfrm>
-          <a:prstGeom prst="rect">
-            <a:avLst/>
-          </a:prstGeom>
-        </p:spPr>
-      </p:pic>
-      <p:sp>
-        <p:nvSpPr>
-          <p:cNvPr id="6" name="TextBox 5"/>
+          <a:noFill/>
+        </p:spPr>
+        <p:txBody>
+          <a:bodyPr wrap="square">
+            <a:spAutoFit/>
+          </a:bodyPr>
+          <a:lstStyle/>
+          <a:p>
+            <a:pPr>
+              <a:spcAft>
+                <a:spcPts val="200"/>
+              </a:spcAft>
+              <a:defRPr b="1" sz="1100">
+                <a:solidFill>
+                  <a:srgbClr val="D97706"/>
+                </a:solidFill>
+              </a:defRPr>
+            </a:pPr>
+            <a:r>
+              <a:t>5. STORAGE, QUEUE &amp; SECURITY</a:t>
+            </a:r>
+          </a:p>
+          <a:p>
+            <a:pPr>
+              <a:defRPr sz="1100">
+                <a:solidFill>
+                  <a:srgbClr val="0F172A"/>
+                </a:solidFill>
+              </a:defRPr>
+            </a:pPr>
+            <a:r>
+              <a:t>SQLite (Local/Edge Dev)  •  Cloud SQL PostgreSQL (Production)  •  Offline SQLite Transaction Queue  •  Redis Queue &amp; Rate Limiter</a:t>
+            </a:r>
+          </a:p>
+        </p:txBody>
+      </p:sp>
+      <p:sp>
+        <p:nvSpPr>
+          <p:cNvPr id="13" name="TextBox 12"/>
           <p:cNvSpPr txBox="1"/>
           <p:nvPr/>
         </p:nvSpPr>
@@ -5107,7 +5833,7 @@
               </a:defRPr>
             </a:pPr>
             <a:r>
-              <a:t>संजीविनी (Sanjeevini) | National Health Resource &amp; Supply Chain Resilience Platform   •   Slide 4 of 10</a:t>
+              <a:t>Sanjeevini | National Health Resource &amp; Supply Chain Resilience Platform   •   Slide 4 of 10</a:t>
             </a:r>
           </a:p>
         </p:txBody>
@@ -5163,7 +5889,7 @@
               </a:defRPr>
             </a:pPr>
             <a:r>
-              <a:t>VOICE-FIRST &amp; VISUAL INGESTION</a:t>
+              <a:t>REAL-TIME OPERATIONAL INTELLIGENCE</a:t>
             </a:r>
           </a:p>
           <a:p>
@@ -5175,7 +5901,7 @@
               </a:defRPr>
             </a:pPr>
             <a:r>
-              <a:t>Frontline Cadre AI: 22 Indic Languages &amp; Multimodal OCR</a:t>
+              <a:t>National Command Center &amp; High-Precision CARTO GIS Surveillance</a:t>
             </a:r>
           </a:p>
         </p:txBody>
@@ -5189,7 +5915,7 @@
         <p:spPr>
           <a:xfrm>
             <a:off x="731520" y="1463040"/>
-            <a:ext cx="4389120" cy="4389120"/>
+            <a:ext cx="4206240" cy="4389120"/>
           </a:xfrm>
           <a:prstGeom prst="rect">
             <a:avLst/>
@@ -5204,7 +5930,7 @@
           <a:p>
             <a:pPr>
               <a:spcAft>
-                <a:spcPts val="1000"/>
+                <a:spcPts val="1200"/>
               </a:spcAft>
               <a:defRPr b="1" sz="1700">
                 <a:solidFill>
@@ -5213,11 +5939,14 @@
               </a:defRPr>
             </a:pPr>
             <a:r>
-              <a:t>Zero-Typing Field Technology for ASHA &amp; ANMs</a:t>
-            </a:r>
-          </a:p>
-          <a:p>
-            <a:pPr>
+              <a:t>Macroscopic Visibility with Micro-Targeting</a:t>
+            </a:r>
+          </a:p>
+          <a:p>
+            <a:pPr>
+              <a:spcAft>
+                <a:spcPts val="1400"/>
+              </a:spcAft>
               <a:defRPr sz="1100">
                 <a:solidFill>
                   <a:srgbClr val="0F172A"/>
@@ -5225,24 +5954,36 @@
               </a:defRPr>
             </a:pPr>
             <a:r>
-              <a:t>• All 22 Official Scheduled Indian Languages + English: Full vernacular coverage spanning Hindi, Bengali, Telugu, Marathi, Tamil, Urdu, Gujarati, Kannada, Malayalam, Odia, Punjabi, Assamese, Maithili, Santhali, Kashmiri, Nepali, Konkani, Sindhi, Dogri, Manipuri, Bodo, Sanskrit, and English.</a:t>
+              <a:t>• Live Monitoring Across 31,000+ PHCs: National command dashboard aggregates medicine inventories, active emergency beds, and doctor attendance continuously.</a:t>
             </a:r>
             <a:br/>
             <a:br/>
             <a:r>
-              <a:t>• Automated Entity Extraction: Frontline cadres speak natural conversational updates; Gemini extracts drug name, count, unit, and clinical urgency flags automatically.</a:t>
+              <a:t>• Epidemic Heat Surveillance: Real-time geofenced cluster zones alert commanders to monsoon waterborne surges (e.g. Cachar flood zone) and vector outbreaks (e.g. Pune dengue surge).</a:t>
             </a:r>
             <a:br/>
             <a:br/>
             <a:r>
-              <a:t>• Gemini Vision Multimodal Scanner: Instantly verifies physical medicine packages, batch barcodes, and handwritten stock ledgers with automated confidence scoring.</a:t>
+              <a:t>• Multi-Tier Governance: Seamless switching between MoHFW National Super-Admin, State Health Directorates, District Health Officers (DHOs), and Ground PHCs.</a:t>
+            </a:r>
+          </a:p>
+          <a:p>
+            <a:pPr>
+              <a:defRPr sz="950" b="1">
+                <a:solidFill>
+                  <a:srgbClr val="059669"/>
+                </a:solidFill>
+              </a:defRPr>
+            </a:pPr>
+            <a:r>
+              <a:t>Layer Support: CARTO Positron (Clean Light), CARTO Voyager, CARTO Dark Matter, OpenStreetMap, and Google Maps.</a:t>
             </a:r>
           </a:p>
         </p:txBody>
       </p:sp>
       <p:pic>
         <p:nvPicPr>
-          <p:cNvPr id="4" name="Picture 3" descr="voice_assistant.png"/>
+          <p:cNvPr id="4" name="Picture 3" descr="national_command.png"/>
           <p:cNvPicPr>
             <a:picLocks noChangeAspect="1"/>
           </p:cNvPicPr>
@@ -5256,8 +5997,8 @@
         </p:blipFill>
         <p:spPr>
           <a:xfrm>
-            <a:off x="5303520" y="1371600"/>
-            <a:ext cx="6126480" cy="3446145"/>
+            <a:off x="5120640" y="1371600"/>
+            <a:ext cx="6309360" cy="3549015"/>
           </a:xfrm>
           <a:prstGeom prst="rect">
             <a:avLst/>
@@ -5266,7 +6007,7 @@
       </p:pic>
       <p:pic>
         <p:nvPicPr>
-          <p:cNvPr id="5" name="Picture 4" descr="multimodal_scan.png"/>
+          <p:cNvPr id="5" name="Picture 4" descr="live_map.png"/>
           <p:cNvPicPr>
             <a:picLocks noChangeAspect="1"/>
           </p:cNvPicPr>
@@ -5280,8 +6021,8 @@
         </p:blipFill>
         <p:spPr>
           <a:xfrm>
-            <a:off x="5303520" y="3931920"/>
-            <a:ext cx="6126480" cy="3446145"/>
+            <a:off x="5120640" y="3840480"/>
+            <a:ext cx="6309360" cy="3549015"/>
           </a:xfrm>
           <a:prstGeom prst="rect">
             <a:avLst/>
@@ -5318,7 +6059,7 @@
               </a:defRPr>
             </a:pPr>
             <a:r>
-              <a:t>संजीविनी (Sanjeevini) | National Health Resource &amp; Supply Chain Resilience Platform   •   Slide 5 of 10</a:t>
+              <a:t>Sanjeevini | National Health Resource &amp; Supply Chain Resilience Platform   •   Slide 5 of 10</a:t>
             </a:r>
           </a:p>
         </p:txBody>
@@ -5374,7 +6115,7 @@
               </a:defRPr>
             </a:pPr>
             <a:r>
-              <a:t>PREDICTIVE SURGE REDISTRIBUTION</a:t>
+              <a:t>VOICE-FIRST &amp; VISUAL INGESTION</a:t>
             </a:r>
           </a:p>
           <a:p>
@@ -5386,7 +6127,7 @@
               </a:defRPr>
             </a:pPr>
             <a:r>
-              <a:t>Automated Cross-District Inventory Balancing &amp; Logistics</a:t>
+              <a:t>Frontline Cadre AI: 22 Indic Languages &amp; Multimodal OCR</a:t>
             </a:r>
           </a:p>
         </p:txBody>
@@ -5424,7 +6165,7 @@
               </a:defRPr>
             </a:pPr>
             <a:r>
-              <a:t>Eliminating Artificial Scarcity with Smart Routing</a:t>
+              <a:t>Zero-Typing Field Technology for ASHA &amp; ANMs</a:t>
             </a:r>
           </a:p>
           <a:p>
@@ -5436,29 +6177,24 @@
               </a:defRPr>
             </a:pPr>
             <a:r>
-              <a:t>• Predictive Surge Lead-Time: ML forecasting detects impending stockouts 7 days in advance, activating transfers long before supplies hit zero.</a:t>
+              <a:t>• All 22 Official Scheduled Indian Languages + English: Full vernacular coverage spanning Hindi, Bengali, Telugu, Marathi, Tamil, Urdu, Gujarati, Kannada, Malayalam, Odia, Punjabi, Assamese, Maithili, Santhali, Kashmiri, Nepali, Konkani, Sindhi, Dogri, Manipuri, Bodo, Sanskrit, and English.</a:t>
             </a:r>
             <a:br/>
             <a:br/>
             <a:r>
-              <a:t>• Surplus-to-Deficit Optimization: Identifies donor facilities with &gt;14 days excess buffer and matches them to clinics with ≤3 days critical stock.</a:t>
+              <a:t>• Automated Entity Extraction: Frontline cadres speak natural conversational updates; Gemini extracts drug name, count, unit, and clinical urgency flags automatically.</a:t>
             </a:r>
             <a:br/>
             <a:br/>
             <a:r>
-              <a:t>• Transit &amp; Cold-Chain Safeguards: Factors in road travel time, distance decay, and vaccine/oxytocin temperature sensitivity.</a:t>
-            </a:r>
-            <a:br/>
-            <a:br/>
-            <a:r>
-              <a:t>• One-Click Transfer Authorizations: Generates digital dispatch manifests, driver route coordinates, and receipt confirmations with full audit trails.</a:t>
+              <a:t>• Gemini Vision Multimodal Scanner: Instantly verifies physical medicine packages, batch barcodes, and handwritten stock ledgers with automated confidence scoring.</a:t>
             </a:r>
           </a:p>
         </p:txBody>
       </p:sp>
       <p:pic>
         <p:nvPicPr>
-          <p:cNvPr id="4" name="Picture 3" descr="logistics.png"/>
+          <p:cNvPr id="4" name="Picture 3" descr="voice_assistant.png"/>
           <p:cNvPicPr>
             <a:picLocks noChangeAspect="1"/>
           </p:cNvPicPr>
@@ -5480,9 +6216,33 @@
           </a:prstGeom>
         </p:spPr>
       </p:pic>
-      <p:sp>
-        <p:nvSpPr>
-          <p:cNvPr id="5" name="TextBox 4"/>
+      <p:pic>
+        <p:nvPicPr>
+          <p:cNvPr id="5" name="Picture 4" descr="multimodal_scan.png"/>
+          <p:cNvPicPr>
+            <a:picLocks noChangeAspect="1"/>
+          </p:cNvPicPr>
+          <p:nvPr/>
+        </p:nvPicPr>
+        <p:blipFill>
+          <a:blip r:embed="rId3"/>
+          <a:stretch>
+            <a:fillRect/>
+          </a:stretch>
+        </p:blipFill>
+        <p:spPr>
+          <a:xfrm>
+            <a:off x="5303520" y="3931920"/>
+            <a:ext cx="6126480" cy="3446145"/>
+          </a:xfrm>
+          <a:prstGeom prst="rect">
+            <a:avLst/>
+          </a:prstGeom>
+        </p:spPr>
+      </p:pic>
+      <p:sp>
+        <p:nvSpPr>
+          <p:cNvPr id="6" name="TextBox 5"/>
           <p:cNvSpPr txBox="1"/>
           <p:nvPr/>
         </p:nvSpPr>
@@ -5510,7 +6270,7 @@
               </a:defRPr>
             </a:pPr>
             <a:r>
-              <a:t>संजीविनी (Sanjeevini) | National Health Resource &amp; Supply Chain Resilience Platform   •   Slide 6 of 10</a:t>
+              <a:t>Sanjeevini | National Health Resource &amp; Supply Chain Resilience Platform   •   Slide 6 of 10</a:t>
             </a:r>
           </a:p>
         </p:txBody>
@@ -5566,7 +6326,7 @@
               </a:defRPr>
             </a:pPr>
             <a:r>
-              <a:t>FEDERATED LEARNING &amp; DPDP COMPLIANCE</a:t>
+              <a:t>PREDICTIVE SURGE REDISTRIBUTION</a:t>
             </a:r>
           </a:p>
           <a:p>
@@ -5578,7 +6338,7 @@
               </a:defRPr>
             </a:pPr>
             <a:r>
-              <a:t>State Data Sovereignty via Federated Model Aggregation</a:t>
+              <a:t>Automated Cross-District Inventory Balancing &amp; Logistics</a:t>
             </a:r>
           </a:p>
         </p:txBody>
@@ -5616,7 +6376,7 @@
               </a:defRPr>
             </a:pPr>
             <a:r>
-              <a:t>Shared Predictive Power Without Centralizing Data</a:t>
+              <a:t>Eliminating Artificial Scarcity with Smart Routing</a:t>
             </a:r>
           </a:p>
           <a:p>
@@ -5628,29 +6388,29 @@
               </a:defRPr>
             </a:pPr>
             <a:r>
-              <a:t>• 100% DPDP Act 2023 Compliance: Sensitive patient health records and facility telemetry remain strictly inside state jurisdictional firewalls.</a:t>
+              <a:t>• Predictive Surge Lead-Time: ML forecasting detects impending stockouts 7 days in advance, activating transfers long before supplies hit zero.</a:t>
             </a:r>
             <a:br/>
             <a:br/>
             <a:r>
-              <a:t>• Local Model Training: State nodes (Maharashtra, Assam, Uttar Pradesh, Tamil Nadu) train localized forecasting models on regional seasonality and disease history.</a:t>
+              <a:t>• Surplus-to-Deficit Optimization: Identifies donor facilities with &gt;14 days excess buffer and matches them to clinics with ≤3 days critical stock.</a:t>
             </a:r>
             <a:br/>
             <a:br/>
             <a:r>
-              <a:t>• FedAvg Gradient Exchange: Only mathematical model weights are sent to the Central Sanjeevini Server for federated aggregation.</a:t>
+              <a:t>• Transit &amp; Cold-Chain Safeguards: Factors in road travel time, distance decay, and vaccine/oxytocin temperature sensitivity.</a:t>
             </a:r>
             <a:br/>
             <a:br/>
             <a:r>
-              <a:t>• 34.2% Higher Forecasting Accuracy: Small rural states benefit from national epidemiological intelligence without surrendering citizen data.</a:t>
+              <a:t>• One-Click Transfer Authorizations: Generates digital dispatch manifests, driver route coordinates, and receipt confirmations with full audit trails.</a:t>
             </a:r>
           </a:p>
         </p:txBody>
       </p:sp>
       <p:pic>
         <p:nvPicPr>
-          <p:cNvPr id="4" name="Picture 3" descr="federated.png"/>
+          <p:cNvPr id="4" name="Picture 3" descr="logistics.png"/>
           <p:cNvPicPr>
             <a:picLocks noChangeAspect="1"/>
           </p:cNvPicPr>
@@ -5702,7 +6462,7 @@
               </a:defRPr>
             </a:pPr>
             <a:r>
-              <a:t>संजीविनी (Sanjeevini) | National Health Resource &amp; Supply Chain Resilience Platform   •   Slide 7 of 10</a:t>
+              <a:t>Sanjeevini | National Health Resource &amp; Supply Chain Resilience Platform   •   Slide 7 of 10</a:t>
             </a:r>
           </a:p>
         </p:txBody>
@@ -5758,7 +6518,7 @@
               </a:defRPr>
             </a:pPr>
             <a:r>
-              <a:t>EXTREME ENVIRONMENT RESILIENCE</a:t>
+              <a:t>FEDERATED LEARNING &amp; DPDP COMPLIANCE</a:t>
             </a:r>
           </a:p>
           <a:p>
@@ -5770,7 +6530,7 @@
               </a:defRPr>
             </a:pPr>
             <a:r>
-              <a:t>Frontline Mobile Simulator: Offline Queue &amp; Sync Mode</a:t>
+              <a:t>State Data Sovereignty via Federated Model Aggregation</a:t>
             </a:r>
           </a:p>
         </p:txBody>
@@ -5808,7 +6568,7 @@
               </a:defRPr>
             </a:pPr>
             <a:r>
-              <a:t>Engineered for Connectivity-Deprived Rural &amp; Tribal Belts</a:t>
+              <a:t>Shared Predictive Power Without Centralizing Data</a:t>
             </a:r>
           </a:p>
           <a:p>
@@ -5820,29 +6580,29 @@
               </a:defRPr>
             </a:pPr>
             <a:r>
-              <a:t>• Offline-First Architecture: In remote villages and disaster flood zones with zero cellular connectivity, health workers can log inventory adjustments, voice notes, and SOS emergencies.</a:t>
+              <a:t>• 100% DPDP Act 2023 Compliance: Sensitive patient health records and facility telemetry remain strictly inside state jurisdictional firewalls.</a:t>
             </a:r>
             <a:br/>
             <a:br/>
             <a:r>
-              <a:t>• Local Transaction Queue: Data is committed safely to local offline storage with cryptographic timestamps.</a:t>
+              <a:t>• Local Model Training: State nodes (Maharashtra, Assam, Uttar Pradesh, Tamil Nadu) train localized forecasting models on regional seasonality and disease history.</a:t>
             </a:r>
             <a:br/>
             <a:br/>
             <a:r>
-              <a:t>• Automatic Cloud Synchronization: As soon as a 2G/3G/4G signal is detected, all queued updates seamlessly synchronize without data collision.</a:t>
+              <a:t>• FedAvg Gradient Exchange: Only mathematical model weights are sent to the Central Sanjeevini Server for federated aggregation.</a:t>
             </a:r>
             <a:br/>
             <a:br/>
             <a:r>
-              <a:t>• One-Touch Emergency SOS: Rapid distress trigger for critical anti-venom, oxygen, or maternal hemorrhage resuscitation.</a:t>
+              <a:t>• 34.2% Higher Forecasting Accuracy: Small rural states benefit from national epidemiological intelligence without surrendering citizen data.</a:t>
             </a:r>
           </a:p>
         </p:txBody>
       </p:sp>
       <p:pic>
         <p:nvPicPr>
-          <p:cNvPr id="4" name="Picture 3" descr="app_simulator.png"/>
+          <p:cNvPr id="4" name="Picture 3" descr="federated.png"/>
           <p:cNvPicPr>
             <a:picLocks noChangeAspect="1"/>
           </p:cNvPicPr>
@@ -5894,7 +6654,7 @@
               </a:defRPr>
             </a:pPr>
             <a:r>
-              <a:t>संजीविनी (Sanjeevini) | National Health Resource &amp; Supply Chain Resilience Platform   •   Slide 8 of 10</a:t>
+              <a:t>Sanjeevini | National Health Resource &amp; Supply Chain Resilience Platform   •   Slide 8 of 10</a:t>
             </a:r>
           </a:p>
         </p:txBody>
@@ -5950,7 +6710,7 @@
               </a:defRPr>
             </a:pPr>
             <a:r>
-              <a:t>MEASURABLE PUBLIC HEALTH OUTCOMES</a:t>
+              <a:t>EXTREME ENVIRONMENT RESILIENCE</a:t>
             </a:r>
           </a:p>
           <a:p>
@@ -5962,66 +6722,21 @@
               </a:defRPr>
             </a:pPr>
             <a:r>
-              <a:t>Transformative Impact: Performance Metrics &amp; Benchmarks</a:t>
-            </a:r>
-          </a:p>
-        </p:txBody>
-      </p:sp>
-      <p:sp>
-        <p:nvSpPr>
-          <p:cNvPr id="3" name="Rounded Rectangle 2"/>
-          <p:cNvSpPr/>
+              <a:t>Frontline Mobile Simulator: Offline Queue &amp; Sync Mode</a:t>
+            </a:r>
+          </a:p>
+        </p:txBody>
+      </p:sp>
+      <p:sp>
+        <p:nvSpPr>
+          <p:cNvPr id="3" name="TextBox 2"/>
+          <p:cNvSpPr txBox="1"/>
           <p:nvPr/>
         </p:nvSpPr>
         <p:spPr>
           <a:xfrm>
             <a:off x="731520" y="1463040"/>
-            <a:ext cx="5257800" cy="2057400"/>
-          </a:xfrm>
-          <a:prstGeom prst="roundRect">
-            <a:avLst/>
-          </a:prstGeom>
-          <a:solidFill>
-            <a:srgbClr val="ECFDF5"/>
-          </a:solidFill>
-          <a:ln w="12700">
-            <a:solidFill>
-              <a:srgbClr val="E2E8F0"/>
-            </a:solidFill>
-          </a:ln>
-        </p:spPr>
-        <p:style>
-          <a:lnRef idx="1">
-            <a:schemeClr val="accent1"/>
-          </a:lnRef>
-          <a:fillRef idx="3">
-            <a:schemeClr val="accent1"/>
-          </a:fillRef>
-          <a:effectRef idx="2">
-            <a:schemeClr val="accent1"/>
-          </a:effectRef>
-          <a:fontRef idx="minor">
-            <a:schemeClr val="lt1"/>
-          </a:fontRef>
-        </p:style>
-        <p:txBody>
-          <a:bodyPr rtlCol="0" anchor="ctr"/>
-          <a:lstStyle/>
-          <a:p>
-            <a:pPr algn="ctr"/>
-          </a:p>
-        </p:txBody>
-      </p:sp>
-      <p:sp>
-        <p:nvSpPr>
-          <p:cNvPr id="4" name="TextBox 3"/>
-          <p:cNvSpPr txBox="1"/>
-          <p:nvPr/>
-        </p:nvSpPr>
-        <p:spPr>
-          <a:xfrm>
-            <a:off x="914400" y="1600200"/>
-            <a:ext cx="4892040" cy="1783080"/>
+            <a:ext cx="4389120" cy="4389120"/>
           </a:xfrm>
           <a:prstGeom prst="rect">
             <a:avLst/>
@@ -6036,380 +6751,74 @@
           <a:p>
             <a:pPr>
               <a:spcAft>
-                <a:spcPts val="400"/>
+                <a:spcPts val="1000"/>
               </a:spcAft>
-              <a:defRPr b="1" sz="1100">
-                <a:solidFill>
-                  <a:srgbClr val="059669"/>
-                </a:solidFill>
-              </a:defRPr>
-            </a:pPr>
-            <a:r>
-              <a:t>99.9% FASTER REPORTING</a:t>
-            </a:r>
-          </a:p>
-          <a:p>
-            <a:pPr>
-              <a:spcAft>
-                <a:spcPts val="600"/>
-              </a:spcAft>
-              <a:defRPr b="1" sz="1800">
+              <a:defRPr b="1" sz="1700">
                 <a:solidFill>
                   <a:srgbClr val="0F172A"/>
                 </a:solidFill>
               </a:defRPr>
             </a:pPr>
             <a:r>
-              <a:t>24h Lag -&gt; 2.4 Seconds</a:t>
-            </a:r>
-          </a:p>
-          <a:p>
-            <a:pPr>
-              <a:defRPr sz="1000">
+              <a:t>Engineered for Connectivity-Deprived Rural &amp; Tribal Belts</a:t>
+            </a:r>
+          </a:p>
+          <a:p>
+            <a:pPr>
+              <a:defRPr sz="1100">
                 <a:solidFill>
                   <a:srgbClr val="0F172A"/>
                 </a:solidFill>
               </a:defRPr>
             </a:pPr>
             <a:r>
-              <a:t>Direct multimodal ingestion replaces physical ledgers, reducing national data visibility lag from 24 hours to sub-3 seconds.</a:t>
-            </a:r>
-          </a:p>
-        </p:txBody>
-      </p:sp>
-      <p:sp>
-        <p:nvSpPr>
-          <p:cNvPr id="5" name="Rounded Rectangle 4"/>
-          <p:cNvSpPr/>
-          <p:nvPr/>
-        </p:nvSpPr>
-        <p:spPr>
-          <a:xfrm>
-            <a:off x="6172200" y="1463040"/>
-            <a:ext cx="5257800" cy="2057400"/>
-          </a:xfrm>
-          <a:prstGeom prst="roundRect">
-            <a:avLst/>
-          </a:prstGeom>
-          <a:solidFill>
-            <a:srgbClr val="FEF2F2"/>
-          </a:solidFill>
-          <a:ln w="12700">
-            <a:solidFill>
-              <a:srgbClr val="E2E8F0"/>
-            </a:solidFill>
-          </a:ln>
-        </p:spPr>
-        <p:style>
-          <a:lnRef idx="1">
-            <a:schemeClr val="accent1"/>
-          </a:lnRef>
-          <a:fillRef idx="3">
-            <a:schemeClr val="accent1"/>
-          </a:fillRef>
-          <a:effectRef idx="2">
-            <a:schemeClr val="accent1"/>
-          </a:effectRef>
-          <a:fontRef idx="minor">
-            <a:schemeClr val="lt1"/>
-          </a:fontRef>
-        </p:style>
-        <p:txBody>
-          <a:bodyPr rtlCol="0" anchor="ctr"/>
-          <a:lstStyle/>
-          <a:p>
-            <a:pPr algn="ctr"/>
-          </a:p>
-        </p:txBody>
-      </p:sp>
-      <p:sp>
-        <p:nvSpPr>
-          <p:cNvPr id="6" name="TextBox 5"/>
-          <p:cNvSpPr txBox="1"/>
-          <p:nvPr/>
-        </p:nvSpPr>
-        <p:spPr>
-          <a:xfrm>
-            <a:off x="6355080" y="1600200"/>
-            <a:ext cx="4892040" cy="1783080"/>
+              <a:t>• Offline-First Architecture: In remote villages and disaster flood zones with zero cellular connectivity, health workers can log inventory adjustments, voice notes, and SOS emergencies.</a:t>
+            </a:r>
+            <a:br/>
+            <a:br/>
+            <a:r>
+              <a:t>• Local SQLite Transaction Queue: Data is committed safely to local offline storage with cryptographic timestamps.</a:t>
+            </a:r>
+            <a:br/>
+            <a:br/>
+            <a:r>
+              <a:t>• Automatic Cloud Synchronization: As soon as a 2G/3G/4G signal is detected, all queued updates seamlessly synchronize without data collision.</a:t>
+            </a:r>
+            <a:br/>
+            <a:br/>
+            <a:r>
+              <a:t>• One-Touch Emergency SOS: Rapid distress trigger for critical anti-venom, oxygen, or maternal hemorrhage resuscitation.</a:t>
+            </a:r>
+          </a:p>
+        </p:txBody>
+      </p:sp>
+      <p:pic>
+        <p:nvPicPr>
+          <p:cNvPr id="4" name="Picture 3" descr="app_simulator.png"/>
+          <p:cNvPicPr>
+            <a:picLocks noChangeAspect="1"/>
+          </p:cNvPicPr>
+          <p:nvPr/>
+        </p:nvPicPr>
+        <p:blipFill>
+          <a:blip r:embed="rId2"/>
+          <a:stretch>
+            <a:fillRect/>
+          </a:stretch>
+        </p:blipFill>
+        <p:spPr>
+          <a:xfrm>
+            <a:off x="5303520" y="1371600"/>
+            <a:ext cx="6126480" cy="3446145"/>
           </a:xfrm>
           <a:prstGeom prst="rect">
             <a:avLst/>
           </a:prstGeom>
-          <a:noFill/>
-        </p:spPr>
-        <p:txBody>
-          <a:bodyPr wrap="square">
-            <a:spAutoFit/>
-          </a:bodyPr>
-          <a:lstStyle/>
-          <a:p>
-            <a:pPr>
-              <a:spcAft>
-                <a:spcPts val="400"/>
-              </a:spcAft>
-              <a:defRPr b="1" sz="1100">
-                <a:solidFill>
-                  <a:srgbClr val="DC2626"/>
-                </a:solidFill>
-              </a:defRPr>
-            </a:pPr>
-            <a:r>
-              <a:t>88.4% STOCKOUT REDUCTION</a:t>
-            </a:r>
-          </a:p>
-          <a:p>
-            <a:pPr>
-              <a:spcAft>
-                <a:spcPts val="600"/>
-              </a:spcAft>
-              <a:defRPr b="1" sz="1800">
-                <a:solidFill>
-                  <a:srgbClr val="0F172A"/>
-                </a:solidFill>
-              </a:defRPr>
-            </a:pPr>
-            <a:r>
-              <a:t>7-Day Early Warnings</a:t>
-            </a:r>
-          </a:p>
-          <a:p>
-            <a:pPr>
-              <a:defRPr sz="1000">
-                <a:solidFill>
-                  <a:srgbClr val="0F172A"/>
-                </a:solidFill>
-              </a:defRPr>
-            </a:pPr>
-            <a:r>
-              <a:t>Proactive predictive surge modeling detects localized supply deficits 7 days ahead, enabling preventive transfers.</a:t>
-            </a:r>
-          </a:p>
-        </p:txBody>
-      </p:sp>
-      <p:sp>
-        <p:nvSpPr>
-          <p:cNvPr id="7" name="Rounded Rectangle 6"/>
-          <p:cNvSpPr/>
-          <p:nvPr/>
-        </p:nvSpPr>
-        <p:spPr>
-          <a:xfrm>
-            <a:off x="731520" y="3749039"/>
-            <a:ext cx="5257800" cy="2057400"/>
-          </a:xfrm>
-          <a:prstGeom prst="roundRect">
-            <a:avLst/>
-          </a:prstGeom>
-          <a:solidFill>
-            <a:srgbClr val="EFF6FF"/>
-          </a:solidFill>
-          <a:ln w="12700">
-            <a:solidFill>
-              <a:srgbClr val="E2E8F0"/>
-            </a:solidFill>
-          </a:ln>
-        </p:spPr>
-        <p:style>
-          <a:lnRef idx="1">
-            <a:schemeClr val="accent1"/>
-          </a:lnRef>
-          <a:fillRef idx="3">
-            <a:schemeClr val="accent1"/>
-          </a:fillRef>
-          <a:effectRef idx="2">
-            <a:schemeClr val="accent1"/>
-          </a:effectRef>
-          <a:fontRef idx="minor">
-            <a:schemeClr val="lt1"/>
-          </a:fontRef>
-        </p:style>
-        <p:txBody>
-          <a:bodyPr rtlCol="0" anchor="ctr"/>
-          <a:lstStyle/>
-          <a:p>
-            <a:pPr algn="ctr"/>
-          </a:p>
-        </p:txBody>
-      </p:sp>
-      <p:sp>
-        <p:nvSpPr>
-          <p:cNvPr id="8" name="TextBox 7"/>
-          <p:cNvSpPr txBox="1"/>
-          <p:nvPr/>
-        </p:nvSpPr>
-        <p:spPr>
-          <a:xfrm>
-            <a:off x="914400" y="3886199"/>
-            <a:ext cx="4892040" cy="1783080"/>
-          </a:xfrm>
-          <a:prstGeom prst="rect">
-            <a:avLst/>
-          </a:prstGeom>
-          <a:noFill/>
-        </p:spPr>
-        <p:txBody>
-          <a:bodyPr wrap="square">
-            <a:spAutoFit/>
-          </a:bodyPr>
-          <a:lstStyle/>
-          <a:p>
-            <a:pPr>
-              <a:spcAft>
-                <a:spcPts val="400"/>
-              </a:spcAft>
-              <a:defRPr b="1" sz="1100">
-                <a:solidFill>
-                  <a:srgbClr val="1E40AF"/>
-                </a:solidFill>
-              </a:defRPr>
-            </a:pPr>
-            <a:r>
-              <a:t>95% SHORTER DISPATCH TAT</a:t>
-            </a:r>
-          </a:p>
-          <a:p>
-            <a:pPr>
-              <a:spcAft>
-                <a:spcPts val="600"/>
-              </a:spcAft>
-              <a:defRPr b="1" sz="1800">
-                <a:solidFill>
-                  <a:srgbClr val="0F172A"/>
-                </a:solidFill>
-              </a:defRPr>
-            </a:pPr>
-            <a:r>
-              <a:t>5 Days -&gt; &lt; 4 Hours</a:t>
-            </a:r>
-          </a:p>
-          <a:p>
-            <a:pPr>
-              <a:defRPr sz="1000">
-                <a:solidFill>
-                  <a:srgbClr val="0F172A"/>
-                </a:solidFill>
-              </a:defRPr>
-            </a:pPr>
-            <a:r>
-              <a:t>Automated donor-to-recipient pairing compresses district transfer authorizations from nearly a week to a single shift.</a:t>
-            </a:r>
-          </a:p>
-        </p:txBody>
-      </p:sp>
-      <p:sp>
-        <p:nvSpPr>
-          <p:cNvPr id="9" name="Rounded Rectangle 8"/>
-          <p:cNvSpPr/>
-          <p:nvPr/>
-        </p:nvSpPr>
-        <p:spPr>
-          <a:xfrm>
-            <a:off x="6172200" y="3749039"/>
-            <a:ext cx="5257800" cy="2057400"/>
-          </a:xfrm>
-          <a:prstGeom prst="roundRect">
-            <a:avLst/>
-          </a:prstGeom>
-          <a:solidFill>
-            <a:srgbClr val="F8FAFC"/>
-          </a:solidFill>
-          <a:ln w="12700">
-            <a:solidFill>
-              <a:srgbClr val="E2E8F0"/>
-            </a:solidFill>
-          </a:ln>
-        </p:spPr>
-        <p:style>
-          <a:lnRef idx="1">
-            <a:schemeClr val="accent1"/>
-          </a:lnRef>
-          <a:fillRef idx="3">
-            <a:schemeClr val="accent1"/>
-          </a:fillRef>
-          <a:effectRef idx="2">
-            <a:schemeClr val="accent1"/>
-          </a:effectRef>
-          <a:fontRef idx="minor">
-            <a:schemeClr val="lt1"/>
-          </a:fontRef>
-        </p:style>
-        <p:txBody>
-          <a:bodyPr rtlCol="0" anchor="ctr"/>
-          <a:lstStyle/>
-          <a:p>
-            <a:pPr algn="ctr"/>
-          </a:p>
-        </p:txBody>
-      </p:sp>
-      <p:sp>
-        <p:nvSpPr>
-          <p:cNvPr id="10" name="TextBox 9"/>
-          <p:cNvSpPr txBox="1"/>
-          <p:nvPr/>
-        </p:nvSpPr>
-        <p:spPr>
-          <a:xfrm>
-            <a:off x="6355080" y="3886199"/>
-            <a:ext cx="4892040" cy="1783080"/>
-          </a:xfrm>
-          <a:prstGeom prst="rect">
-            <a:avLst/>
-          </a:prstGeom>
-          <a:noFill/>
-        </p:spPr>
-        <p:txBody>
-          <a:bodyPr wrap="square">
-            <a:spAutoFit/>
-          </a:bodyPr>
-          <a:lstStyle/>
-          <a:p>
-            <a:pPr>
-              <a:spcAft>
-                <a:spcPts val="400"/>
-              </a:spcAft>
-              <a:defRPr b="1" sz="1100">
-                <a:solidFill>
-                  <a:srgbClr val="D97706"/>
-                </a:solidFill>
-              </a:defRPr>
-            </a:pPr>
-            <a:r>
-              <a:t>2.5 HRS SAVED / DAY / WORKER</a:t>
-            </a:r>
-          </a:p>
-          <a:p>
-            <a:pPr>
-              <a:spcAft>
-                <a:spcPts val="600"/>
-              </a:spcAft>
-              <a:defRPr b="1" sz="1800">
-                <a:solidFill>
-                  <a:srgbClr val="0F172A"/>
-                </a:solidFill>
-              </a:defRPr>
-            </a:pPr>
-            <a:r>
-              <a:t>Zero Manual Paperwork</a:t>
-            </a:r>
-          </a:p>
-          <a:p>
-            <a:pPr>
-              <a:defRPr sz="1000">
-                <a:solidFill>
-                  <a:srgbClr val="0F172A"/>
-                </a:solidFill>
-              </a:defRPr>
-            </a:pPr>
-            <a:r>
-              <a:t>Indic conversational voice logging eliminates daily paperwork burden for over 1 million ASHA and ANM healthcare workers.</a:t>
-            </a:r>
-          </a:p>
-        </p:txBody>
-      </p:sp>
-      <p:sp>
-        <p:nvSpPr>
-          <p:cNvPr id="11" name="TextBox 10"/>
+        </p:spPr>
+      </p:pic>
+      <p:sp>
+        <p:nvSpPr>
+          <p:cNvPr id="5" name="TextBox 4"/>
           <p:cNvSpPr txBox="1"/>
           <p:nvPr/>
         </p:nvSpPr>
@@ -6437,7 +6846,7 @@
               </a:defRPr>
             </a:pPr>
             <a:r>
-              <a:t>संजीविनी (Sanjeevini) | National Health Resource &amp; Supply Chain Resilience Platform   •   Slide 9 of 10</a:t>
+              <a:t>Sanjeevini | National Health Resource &amp; Supply Chain Resilience Platform   •   Slide 9 of 10</a:t>
             </a:r>
           </a:p>
         </p:txBody>

</xml_diff>

<commit_message>
docs(pitch-deck): add dedicated System Architecture Flow Diagram slide after technical architecture
</commit_message>
<xml_diff>
--- a/Pitch-DECK/Sanjeevini-Pitch-Deck.pptx
+++ b/Pitch-DECK/Sanjeevini-Pitch-Deck.pptx
@@ -15,6 +15,7 @@
     <p:sldId id="263" r:id="rId14"/>
     <p:sldId id="264" r:id="rId15"/>
     <p:sldId id="265" r:id="rId16"/>
+    <p:sldId id="266" r:id="rId17"/>
   </p:sldIdLst>
   <p:sldSz cx="12191695" cy="6858000" type="screen4x3"/>
   <p:notesSz cx="6858000" cy="9144000"/>
@@ -3280,7 +3281,7 @@
               </a:defRPr>
             </a:pPr>
             <a:r>
-              <a:t>Sanjeevini | National Health Resource &amp; Supply Chain Resilience Platform   •   Slide 1 of 10</a:t>
+              <a:t>Sanjeevini | National Health Resource &amp; Supply Chain Resilience Platform   •   Slide 1 of 11</a:t>
             </a:r>
           </a:p>
         </p:txBody>
@@ -3336,6 +3337,198 @@
               </a:defRPr>
             </a:pPr>
             <a:r>
+              <a:t>EXTREME ENVIRONMENT RESILIENCE</a:t>
+            </a:r>
+          </a:p>
+          <a:p>
+            <a:pPr>
+              <a:defRPr sz="2200" b="1">
+                <a:solidFill>
+                  <a:srgbClr val="0F172A"/>
+                </a:solidFill>
+              </a:defRPr>
+            </a:pPr>
+            <a:r>
+              <a:t>Frontline Mobile Simulator: Offline Queue &amp; Sync Mode</a:t>
+            </a:r>
+          </a:p>
+        </p:txBody>
+      </p:sp>
+      <p:sp>
+        <p:nvSpPr>
+          <p:cNvPr id="3" name="TextBox 2"/>
+          <p:cNvSpPr txBox="1"/>
+          <p:nvPr/>
+        </p:nvSpPr>
+        <p:spPr>
+          <a:xfrm>
+            <a:off x="731520" y="1463040"/>
+            <a:ext cx="4389120" cy="4389120"/>
+          </a:xfrm>
+          <a:prstGeom prst="rect">
+            <a:avLst/>
+          </a:prstGeom>
+          <a:noFill/>
+        </p:spPr>
+        <p:txBody>
+          <a:bodyPr wrap="square">
+            <a:spAutoFit/>
+          </a:bodyPr>
+          <a:lstStyle/>
+          <a:p>
+            <a:pPr>
+              <a:spcAft>
+                <a:spcPts val="1000"/>
+              </a:spcAft>
+              <a:defRPr b="1" sz="1700">
+                <a:solidFill>
+                  <a:srgbClr val="0F172A"/>
+                </a:solidFill>
+              </a:defRPr>
+            </a:pPr>
+            <a:r>
+              <a:t>Engineered for Connectivity-Deprived Rural &amp; Tribal Belts</a:t>
+            </a:r>
+          </a:p>
+          <a:p>
+            <a:pPr>
+              <a:defRPr sz="1100">
+                <a:solidFill>
+                  <a:srgbClr val="0F172A"/>
+                </a:solidFill>
+              </a:defRPr>
+            </a:pPr>
+            <a:r>
+              <a:t>• Offline-First Architecture: In remote villages and disaster flood zones with zero cellular connectivity, health workers can log inventory adjustments, voice notes, and SOS emergencies.</a:t>
+            </a:r>
+            <a:br/>
+            <a:br/>
+            <a:r>
+              <a:t>• Local SQLite Transaction Queue: Data is committed safely to local offline storage with cryptographic timestamps.</a:t>
+            </a:r>
+            <a:br/>
+            <a:br/>
+            <a:r>
+              <a:t>• Automatic Cloud Synchronization: As soon as a 2G/3G/4G signal is detected, all queued updates seamlessly synchronize without data collision.</a:t>
+            </a:r>
+            <a:br/>
+            <a:br/>
+            <a:r>
+              <a:t>• One-Touch Emergency SOS: Rapid distress trigger for critical anti-venom, oxygen, or maternal hemorrhage resuscitation.</a:t>
+            </a:r>
+          </a:p>
+        </p:txBody>
+      </p:sp>
+      <p:pic>
+        <p:nvPicPr>
+          <p:cNvPr id="4" name="Picture 3" descr="app_simulator.png"/>
+          <p:cNvPicPr>
+            <a:picLocks noChangeAspect="1"/>
+          </p:cNvPicPr>
+          <p:nvPr/>
+        </p:nvPicPr>
+        <p:blipFill>
+          <a:blip r:embed="rId2"/>
+          <a:stretch>
+            <a:fillRect/>
+          </a:stretch>
+        </p:blipFill>
+        <p:spPr>
+          <a:xfrm>
+            <a:off x="5303520" y="1371600"/>
+            <a:ext cx="6126480" cy="3446145"/>
+          </a:xfrm>
+          <a:prstGeom prst="rect">
+            <a:avLst/>
+          </a:prstGeom>
+        </p:spPr>
+      </p:pic>
+      <p:sp>
+        <p:nvSpPr>
+          <p:cNvPr id="5" name="TextBox 4"/>
+          <p:cNvSpPr txBox="1"/>
+          <p:nvPr/>
+        </p:nvSpPr>
+        <p:spPr>
+          <a:xfrm>
+            <a:off x="731520" y="6446520"/>
+            <a:ext cx="10728655" cy="320040"/>
+          </a:xfrm>
+          <a:prstGeom prst="rect">
+            <a:avLst/>
+          </a:prstGeom>
+          <a:noFill/>
+        </p:spPr>
+        <p:txBody>
+          <a:bodyPr wrap="square" lIns="0" tIns="0" rIns="0" bIns="0">
+            <a:spAutoFit/>
+          </a:bodyPr>
+          <a:lstStyle/>
+          <a:p>
+            <a:pPr>
+              <a:defRPr sz="900">
+                <a:solidFill>
+                  <a:srgbClr val="64748B"/>
+                </a:solidFill>
+              </a:defRPr>
+            </a:pPr>
+            <a:r>
+              <a:t>Sanjeevini | National Health Resource &amp; Supply Chain Resilience Platform   •   Slide 10 of 11</a:t>
+            </a:r>
+          </a:p>
+        </p:txBody>
+      </p:sp>
+    </p:spTree>
+  </p:cSld>
+  <p:clrMapOvr>
+    <a:masterClrMapping/>
+  </p:clrMapOvr>
+</p:sld>
+</file>
+
+<file path=ppt/slides/slide11.xml><?xml version="1.0" encoding="utf-8"?>
+<p:sld xmlns:a="http://schemas.openxmlformats.org/drawingml/2006/main" xmlns:p="http://schemas.openxmlformats.org/presentationml/2006/main" xmlns:r="http://schemas.openxmlformats.org/officeDocument/2006/relationships">
+  <p:cSld>
+    <p:spTree>
+      <p:nvGrpSpPr>
+        <p:cNvPr id="1" name=""/>
+        <p:cNvGrpSpPr/>
+        <p:nvPr/>
+      </p:nvGrpSpPr>
+      <p:grpSpPr/>
+      <p:sp>
+        <p:nvSpPr>
+          <p:cNvPr id="2" name="TextBox 1"/>
+          <p:cNvSpPr txBox="1"/>
+          <p:nvPr/>
+        </p:nvSpPr>
+        <p:spPr>
+          <a:xfrm>
+            <a:off x="731520" y="365760"/>
+            <a:ext cx="10728655" cy="822960"/>
+          </a:xfrm>
+          <a:prstGeom prst="rect">
+            <a:avLst/>
+          </a:prstGeom>
+          <a:noFill/>
+        </p:spPr>
+        <p:txBody>
+          <a:bodyPr wrap="square" lIns="0" tIns="0" rIns="0" bIns="0">
+            <a:spAutoFit/>
+          </a:bodyPr>
+          <a:lstStyle/>
+          <a:p>
+            <a:pPr>
+              <a:spcAft>
+                <a:spcPts val="200"/>
+              </a:spcAft>
+              <a:defRPr sz="1000" b="1">
+                <a:solidFill>
+                  <a:srgbClr val="059669"/>
+                </a:solidFill>
+              </a:defRPr>
+            </a:pPr>
+            <a:r>
               <a:t>MEASURABLE OUTCOMES &amp; SCALING ROADMAP</a:t>
             </a:r>
           </a:p>
@@ -4212,7 +4405,7 @@
               </a:defRPr>
             </a:pPr>
             <a:r>
-              <a:t>Sanjeevini | National Health Resource &amp; Supply Chain Resilience Platform   •   Slide 10 of 10</a:t>
+              <a:t>Sanjeevini | National Health Resource &amp; Supply Chain Resilience Platform   •   Slide 11 of 11</a:t>
             </a:r>
           </a:p>
         </p:txBody>
@@ -4660,7 +4853,7 @@
               </a:defRPr>
             </a:pPr>
             <a:r>
-              <a:t>Sanjeevini | National Health Resource &amp; Supply Chain Resilience Platform   •   Slide 2 of 10</a:t>
+              <a:t>Sanjeevini | National Health Resource &amp; Supply Chain Resilience Platform   •   Slide 2 of 11</a:t>
             </a:r>
           </a:p>
         </p:txBody>
@@ -5255,7 +5448,7 @@
               </a:defRPr>
             </a:pPr>
             <a:r>
-              <a:t>Sanjeevini | National Health Resource &amp; Supply Chain Resilience Platform   •   Slide 3 of 10</a:t>
+              <a:t>Sanjeevini | National Health Resource &amp; Supply Chain Resilience Platform   •   Slide 3 of 11</a:t>
             </a:r>
           </a:p>
         </p:txBody>
@@ -5311,7 +5504,7 @@
               </a:defRPr>
             </a:pPr>
             <a:r>
-              <a:t>5-TIER CLOUD &amp; EDGE INFRASTRUCTURE</a:t>
+              <a:t>5-TIER CLOUD &amp; EDGE INFRASTRUCTURE (FROM README)</a:t>
             </a:r>
           </a:p>
           <a:p>
@@ -5833,7 +6026,7 @@
               </a:defRPr>
             </a:pPr>
             <a:r>
-              <a:t>Sanjeevini | National Health Resource &amp; Supply Chain Resilience Platform   •   Slide 4 of 10</a:t>
+              <a:t>Sanjeevini | National Health Resource &amp; Supply Chain Resilience Platform   •   Slide 4 of 11</a:t>
             </a:r>
           </a:p>
         </p:txBody>
@@ -5889,7 +6082,7 @@
               </a:defRPr>
             </a:pPr>
             <a:r>
-              <a:t>REAL-TIME OPERATIONAL INTELLIGENCE</a:t>
+              <a:t>PIPELINE FLOW &amp; DATA TELEMETRY (README FLOWCHART)</a:t>
             </a:r>
           </a:p>
           <a:p>
@@ -5901,89 +6094,14 @@
               </a:defRPr>
             </a:pPr>
             <a:r>
-              <a:t>National Command Center &amp; High-Precision CARTO GIS Surveillance</a:t>
-            </a:r>
-          </a:p>
-        </p:txBody>
-      </p:sp>
-      <p:sp>
-        <p:nvSpPr>
-          <p:cNvPr id="3" name="TextBox 2"/>
-          <p:cNvSpPr txBox="1"/>
-          <p:nvPr/>
-        </p:nvSpPr>
-        <p:spPr>
-          <a:xfrm>
-            <a:off x="731520" y="1463040"/>
-            <a:ext cx="4206240" cy="4389120"/>
-          </a:xfrm>
-          <a:prstGeom prst="rect">
-            <a:avLst/>
-          </a:prstGeom>
-          <a:noFill/>
-        </p:spPr>
-        <p:txBody>
-          <a:bodyPr wrap="square">
-            <a:spAutoFit/>
-          </a:bodyPr>
-          <a:lstStyle/>
-          <a:p>
-            <a:pPr>
-              <a:spcAft>
-                <a:spcPts val="1200"/>
-              </a:spcAft>
-              <a:defRPr b="1" sz="1700">
-                <a:solidFill>
-                  <a:srgbClr val="0F172A"/>
-                </a:solidFill>
-              </a:defRPr>
-            </a:pPr>
-            <a:r>
-              <a:t>Macroscopic Visibility with Micro-Targeting</a:t>
-            </a:r>
-          </a:p>
-          <a:p>
-            <a:pPr>
-              <a:spcAft>
-                <a:spcPts val="1400"/>
-              </a:spcAft>
-              <a:defRPr sz="1100">
-                <a:solidFill>
-                  <a:srgbClr val="0F172A"/>
-                </a:solidFill>
-              </a:defRPr>
-            </a:pPr>
-            <a:r>
-              <a:t>• Live Monitoring Across 31,000+ PHCs: National command dashboard aggregates medicine inventories, active emergency beds, and doctor attendance continuously.</a:t>
-            </a:r>
-            <a:br/>
-            <a:br/>
-            <a:r>
-              <a:t>• Epidemic Heat Surveillance: Real-time geofenced cluster zones alert commanders to monsoon waterborne surges (e.g. Cachar flood zone) and vector outbreaks (e.g. Pune dengue surge).</a:t>
-            </a:r>
-            <a:br/>
-            <a:br/>
-            <a:r>
-              <a:t>• Multi-Tier Governance: Seamless switching between MoHFW National Super-Admin, State Health Directorates, District Health Officers (DHOs), and Ground PHCs.</a:t>
-            </a:r>
-          </a:p>
-          <a:p>
-            <a:pPr>
-              <a:defRPr sz="950" b="1">
-                <a:solidFill>
-                  <a:srgbClr val="059669"/>
-                </a:solidFill>
-              </a:defRPr>
-            </a:pPr>
-            <a:r>
-              <a:t>Layer Support: CARTO Positron (Clean Light), CARTO Voyager, CARTO Dark Matter, OpenStreetMap, and Google Maps.</a:t>
+              <a:t>System Architecture Flow: End-to-End Pipeline &amp; Integrations</a:t>
             </a:r>
           </a:p>
         </p:txBody>
       </p:sp>
       <p:pic>
         <p:nvPicPr>
-          <p:cNvPr id="4" name="Picture 3" descr="national_command.png"/>
+          <p:cNvPr id="3" name="Picture 2" descr="system_architecture_diagram.png"/>
           <p:cNvPicPr>
             <a:picLocks noChangeAspect="1"/>
           </p:cNvPicPr>
@@ -5997,38 +6115,113 @@
         </p:blipFill>
         <p:spPr>
           <a:xfrm>
-            <a:off x="5120640" y="1371600"/>
-            <a:ext cx="6309360" cy="3549015"/>
+            <a:off x="731520" y="1371600"/>
+            <a:ext cx="10728655" cy="3792747"/>
           </a:xfrm>
           <a:prstGeom prst="rect">
             <a:avLst/>
           </a:prstGeom>
         </p:spPr>
       </p:pic>
-      <p:pic>
-        <p:nvPicPr>
-          <p:cNvPr id="5" name="Picture 4" descr="live_map.png"/>
-          <p:cNvPicPr>
-            <a:picLocks noChangeAspect="1"/>
-          </p:cNvPicPr>
-          <p:nvPr/>
-        </p:nvPicPr>
-        <p:blipFill>
-          <a:blip r:embed="rId3"/>
-          <a:stretch>
-            <a:fillRect/>
-          </a:stretch>
-        </p:blipFill>
-        <p:spPr>
-          <a:xfrm>
-            <a:off x="5120640" y="3840480"/>
-            <a:ext cx="6309360" cy="3549015"/>
+      <p:sp>
+        <p:nvSpPr>
+          <p:cNvPr id="4" name="Rounded Rectangle 3"/>
+          <p:cNvSpPr/>
+          <p:nvPr/>
+        </p:nvSpPr>
+        <p:spPr>
+          <a:xfrm>
+            <a:off x="731520" y="5303520"/>
+            <a:ext cx="10728655" cy="960120"/>
+          </a:xfrm>
+          <a:prstGeom prst="roundRect">
+            <a:avLst/>
+          </a:prstGeom>
+          <a:solidFill>
+            <a:srgbClr val="F8FAFC"/>
+          </a:solidFill>
+          <a:ln w="12700">
+            <a:solidFill>
+              <a:srgbClr val="E2E8F0"/>
+            </a:solidFill>
+          </a:ln>
+        </p:spPr>
+        <p:style>
+          <a:lnRef idx="1">
+            <a:schemeClr val="accent1"/>
+          </a:lnRef>
+          <a:fillRef idx="3">
+            <a:schemeClr val="accent1"/>
+          </a:fillRef>
+          <a:effectRef idx="2">
+            <a:schemeClr val="accent1"/>
+          </a:effectRef>
+          <a:fontRef idx="minor">
+            <a:schemeClr val="lt1"/>
+          </a:fontRef>
+        </p:style>
+        <p:txBody>
+          <a:bodyPr rtlCol="0" anchor="ctr"/>
+          <a:lstStyle/>
+          <a:p>
+            <a:pPr algn="ctr"/>
+          </a:p>
+        </p:txBody>
+      </p:sp>
+      <p:sp>
+        <p:nvSpPr>
+          <p:cNvPr id="5" name="TextBox 4"/>
+          <p:cNvSpPr txBox="1"/>
+          <p:nvPr/>
+        </p:nvSpPr>
+        <p:spPr>
+          <a:xfrm>
+            <a:off x="914400" y="5376672"/>
+            <a:ext cx="10362895" cy="822960"/>
           </a:xfrm>
           <a:prstGeom prst="rect">
             <a:avLst/>
           </a:prstGeom>
-        </p:spPr>
-      </p:pic>
+          <a:noFill/>
+        </p:spPr>
+        <p:txBody>
+          <a:bodyPr wrap="square">
+            <a:spAutoFit/>
+          </a:bodyPr>
+          <a:lstStyle/>
+          <a:p>
+            <a:pPr>
+              <a:spcAft>
+                <a:spcPts val="200"/>
+              </a:spcAft>
+              <a:defRPr b="1" sz="1000">
+                <a:solidFill>
+                  <a:srgbClr val="059669"/>
+                </a:solidFill>
+              </a:defRPr>
+            </a:pPr>
+            <a:r>
+              <a:t>CORE TELEMETRY PATHWAYS:</a:t>
+            </a:r>
+          </a:p>
+          <a:p>
+            <a:pPr>
+              <a:defRPr sz="1050">
+                <a:solidFill>
+                  <a:srgbClr val="0F172A"/>
+                </a:solidFill>
+              </a:defRPr>
+            </a:pPr>
+            <a:r>
+              <a:t>• Voice &amp; OCR Ingestion: ASHA voice memos and PHC ledger photos flow via Web Speech/Canvas to FastAPI -&gt; Gemini 1.5 Flash Vision &amp; STT.</a:t>
+            </a:r>
+            <a:br/>
+            <a:r>
+              <a:t>• Logistics &amp; Surveillance: DHO approvals and MoHFW telemetry route through Vertex AI demand matching and BigQuery public health bridges.</a:t>
+            </a:r>
+          </a:p>
+        </p:txBody>
+      </p:sp>
       <p:sp>
         <p:nvSpPr>
           <p:cNvPr id="6" name="TextBox 5"/>
@@ -6059,7 +6252,7 @@
               </a:defRPr>
             </a:pPr>
             <a:r>
-              <a:t>Sanjeevini | National Health Resource &amp; Supply Chain Resilience Platform   •   Slide 5 of 10</a:t>
+              <a:t>Sanjeevini | National Health Resource &amp; Supply Chain Resilience Platform   •   Slide 5 of 11</a:t>
             </a:r>
           </a:p>
         </p:txBody>
@@ -6115,7 +6308,7 @@
               </a:defRPr>
             </a:pPr>
             <a:r>
-              <a:t>VOICE-FIRST &amp; VISUAL INGESTION</a:t>
+              <a:t>REAL-TIME OPERATIONAL INTELLIGENCE</a:t>
             </a:r>
           </a:p>
           <a:p>
@@ -6127,7 +6320,7 @@
               </a:defRPr>
             </a:pPr>
             <a:r>
-              <a:t>Frontline Cadre AI: 22 Indic Languages &amp; Multimodal OCR</a:t>
+              <a:t>National Command Center &amp; High-Precision CARTO GIS Surveillance</a:t>
             </a:r>
           </a:p>
         </p:txBody>
@@ -6141,7 +6334,7 @@
         <p:spPr>
           <a:xfrm>
             <a:off x="731520" y="1463040"/>
-            <a:ext cx="4389120" cy="4389120"/>
+            <a:ext cx="4206240" cy="4389120"/>
           </a:xfrm>
           <a:prstGeom prst="rect">
             <a:avLst/>
@@ -6156,7 +6349,7 @@
           <a:p>
             <a:pPr>
               <a:spcAft>
-                <a:spcPts val="1000"/>
+                <a:spcPts val="1200"/>
               </a:spcAft>
               <a:defRPr b="1" sz="1700">
                 <a:solidFill>
@@ -6165,11 +6358,14 @@
               </a:defRPr>
             </a:pPr>
             <a:r>
-              <a:t>Zero-Typing Field Technology for ASHA &amp; ANMs</a:t>
-            </a:r>
-          </a:p>
-          <a:p>
-            <a:pPr>
+              <a:t>Macroscopic Visibility with Micro-Targeting</a:t>
+            </a:r>
+          </a:p>
+          <a:p>
+            <a:pPr>
+              <a:spcAft>
+                <a:spcPts val="1400"/>
+              </a:spcAft>
               <a:defRPr sz="1100">
                 <a:solidFill>
                   <a:srgbClr val="0F172A"/>
@@ -6177,24 +6373,36 @@
               </a:defRPr>
             </a:pPr>
             <a:r>
-              <a:t>• All 22 Official Scheduled Indian Languages + English: Full vernacular coverage spanning Hindi, Bengali, Telugu, Marathi, Tamil, Urdu, Gujarati, Kannada, Malayalam, Odia, Punjabi, Assamese, Maithili, Santhali, Kashmiri, Nepali, Konkani, Sindhi, Dogri, Manipuri, Bodo, Sanskrit, and English.</a:t>
+              <a:t>• Live Monitoring Across 31,000+ PHCs: National command dashboard aggregates medicine inventories, active emergency beds, and doctor attendance continuously.</a:t>
             </a:r>
             <a:br/>
             <a:br/>
             <a:r>
-              <a:t>• Automated Entity Extraction: Frontline cadres speak natural conversational updates; Gemini extracts drug name, count, unit, and clinical urgency flags automatically.</a:t>
+              <a:t>• Epidemic Heat Surveillance: Real-time geofenced cluster zones alert commanders to monsoon waterborne surges (e.g. Cachar flood zone) and vector outbreaks (e.g. Pune dengue surge).</a:t>
             </a:r>
             <a:br/>
             <a:br/>
             <a:r>
-              <a:t>• Gemini Vision Multimodal Scanner: Instantly verifies physical medicine packages, batch barcodes, and handwritten stock ledgers with automated confidence scoring.</a:t>
+              <a:t>• Multi-Tier Governance: Seamless switching between MoHFW National Super-Admin, State Health Directorates, District Health Officers (DHOs), and Ground PHCs.</a:t>
+            </a:r>
+          </a:p>
+          <a:p>
+            <a:pPr>
+              <a:defRPr sz="950" b="1">
+                <a:solidFill>
+                  <a:srgbClr val="059669"/>
+                </a:solidFill>
+              </a:defRPr>
+            </a:pPr>
+            <a:r>
+              <a:t>Layer Support: CARTO Positron (Clean Light), CARTO Voyager, CARTO Dark Matter, OpenStreetMap, and Google Maps.</a:t>
             </a:r>
           </a:p>
         </p:txBody>
       </p:sp>
       <p:pic>
         <p:nvPicPr>
-          <p:cNvPr id="4" name="Picture 3" descr="voice_assistant.png"/>
+          <p:cNvPr id="4" name="Picture 3" descr="national_command.png"/>
           <p:cNvPicPr>
             <a:picLocks noChangeAspect="1"/>
           </p:cNvPicPr>
@@ -6208,8 +6416,8 @@
         </p:blipFill>
         <p:spPr>
           <a:xfrm>
-            <a:off x="5303520" y="1371600"/>
-            <a:ext cx="6126480" cy="3446145"/>
+            <a:off x="5120640" y="1371600"/>
+            <a:ext cx="6309360" cy="3549015"/>
           </a:xfrm>
           <a:prstGeom prst="rect">
             <a:avLst/>
@@ -6218,7 +6426,7 @@
       </p:pic>
       <p:pic>
         <p:nvPicPr>
-          <p:cNvPr id="5" name="Picture 4" descr="multimodal_scan.png"/>
+          <p:cNvPr id="5" name="Picture 4" descr="live_map.png"/>
           <p:cNvPicPr>
             <a:picLocks noChangeAspect="1"/>
           </p:cNvPicPr>
@@ -6232,8 +6440,8 @@
         </p:blipFill>
         <p:spPr>
           <a:xfrm>
-            <a:off x="5303520" y="3931920"/>
-            <a:ext cx="6126480" cy="3446145"/>
+            <a:off x="5120640" y="3840480"/>
+            <a:ext cx="6309360" cy="3549015"/>
           </a:xfrm>
           <a:prstGeom prst="rect">
             <a:avLst/>
@@ -6270,7 +6478,7 @@
               </a:defRPr>
             </a:pPr>
             <a:r>
-              <a:t>Sanjeevini | National Health Resource &amp; Supply Chain Resilience Platform   •   Slide 6 of 10</a:t>
+              <a:t>Sanjeevini | National Health Resource &amp; Supply Chain Resilience Platform   •   Slide 6 of 11</a:t>
             </a:r>
           </a:p>
         </p:txBody>
@@ -6326,7 +6534,7 @@
               </a:defRPr>
             </a:pPr>
             <a:r>
-              <a:t>PREDICTIVE SURGE REDISTRIBUTION</a:t>
+              <a:t>VOICE-FIRST &amp; VISUAL INGESTION</a:t>
             </a:r>
           </a:p>
           <a:p>
@@ -6338,7 +6546,7 @@
               </a:defRPr>
             </a:pPr>
             <a:r>
-              <a:t>Automated Cross-District Inventory Balancing &amp; Logistics</a:t>
+              <a:t>Frontline Cadre AI: 22 Indic Languages &amp; Multimodal OCR</a:t>
             </a:r>
           </a:p>
         </p:txBody>
@@ -6376,7 +6584,7 @@
               </a:defRPr>
             </a:pPr>
             <a:r>
-              <a:t>Eliminating Artificial Scarcity with Smart Routing</a:t>
+              <a:t>Zero-Typing Field Technology for ASHA &amp; ANMs</a:t>
             </a:r>
           </a:p>
           <a:p>
@@ -6388,29 +6596,24 @@
               </a:defRPr>
             </a:pPr>
             <a:r>
-              <a:t>• Predictive Surge Lead-Time: ML forecasting detects impending stockouts 7 days in advance, activating transfers long before supplies hit zero.</a:t>
+              <a:t>• All 22 Official Scheduled Indian Languages + English: Full vernacular coverage spanning Hindi, Bengali, Telugu, Marathi, Tamil, Urdu, Gujarati, Kannada, Malayalam, Odia, Punjabi, Assamese, Maithili, Santhali, Kashmiri, Nepali, Konkani, Sindhi, Dogri, Manipuri, Bodo, Sanskrit, and English.</a:t>
             </a:r>
             <a:br/>
             <a:br/>
             <a:r>
-              <a:t>• Surplus-to-Deficit Optimization: Identifies donor facilities with &gt;14 days excess buffer and matches them to clinics with ≤3 days critical stock.</a:t>
+              <a:t>• Automated Entity Extraction: Frontline cadres speak natural conversational updates; Gemini extracts drug name, count, unit, and clinical urgency flags automatically.</a:t>
             </a:r>
             <a:br/>
             <a:br/>
             <a:r>
-              <a:t>• Transit &amp; Cold-Chain Safeguards: Factors in road travel time, distance decay, and vaccine/oxytocin temperature sensitivity.</a:t>
-            </a:r>
-            <a:br/>
-            <a:br/>
-            <a:r>
-              <a:t>• One-Click Transfer Authorizations: Generates digital dispatch manifests, driver route coordinates, and receipt confirmations with full audit trails.</a:t>
+              <a:t>• Gemini Vision Multimodal Scanner: Instantly verifies physical medicine packages, batch barcodes, and handwritten stock ledgers with automated confidence scoring.</a:t>
             </a:r>
           </a:p>
         </p:txBody>
       </p:sp>
       <p:pic>
         <p:nvPicPr>
-          <p:cNvPr id="4" name="Picture 3" descr="logistics.png"/>
+          <p:cNvPr id="4" name="Picture 3" descr="voice_assistant.png"/>
           <p:cNvPicPr>
             <a:picLocks noChangeAspect="1"/>
           </p:cNvPicPr>
@@ -6432,9 +6635,33 @@
           </a:prstGeom>
         </p:spPr>
       </p:pic>
-      <p:sp>
-        <p:nvSpPr>
-          <p:cNvPr id="5" name="TextBox 4"/>
+      <p:pic>
+        <p:nvPicPr>
+          <p:cNvPr id="5" name="Picture 4" descr="multimodal_scan.png"/>
+          <p:cNvPicPr>
+            <a:picLocks noChangeAspect="1"/>
+          </p:cNvPicPr>
+          <p:nvPr/>
+        </p:nvPicPr>
+        <p:blipFill>
+          <a:blip r:embed="rId3"/>
+          <a:stretch>
+            <a:fillRect/>
+          </a:stretch>
+        </p:blipFill>
+        <p:spPr>
+          <a:xfrm>
+            <a:off x="5303520" y="3931920"/>
+            <a:ext cx="6126480" cy="3446145"/>
+          </a:xfrm>
+          <a:prstGeom prst="rect">
+            <a:avLst/>
+          </a:prstGeom>
+        </p:spPr>
+      </p:pic>
+      <p:sp>
+        <p:nvSpPr>
+          <p:cNvPr id="6" name="TextBox 5"/>
           <p:cNvSpPr txBox="1"/>
           <p:nvPr/>
         </p:nvSpPr>
@@ -6462,7 +6689,7 @@
               </a:defRPr>
             </a:pPr>
             <a:r>
-              <a:t>Sanjeevini | National Health Resource &amp; Supply Chain Resilience Platform   •   Slide 7 of 10</a:t>
+              <a:t>Sanjeevini | National Health Resource &amp; Supply Chain Resilience Platform   •   Slide 7 of 11</a:t>
             </a:r>
           </a:p>
         </p:txBody>
@@ -6518,7 +6745,7 @@
               </a:defRPr>
             </a:pPr>
             <a:r>
-              <a:t>FEDERATED LEARNING &amp; DPDP COMPLIANCE</a:t>
+              <a:t>PREDICTIVE SURGE REDISTRIBUTION</a:t>
             </a:r>
           </a:p>
           <a:p>
@@ -6530,7 +6757,7 @@
               </a:defRPr>
             </a:pPr>
             <a:r>
-              <a:t>State Data Sovereignty via Federated Model Aggregation</a:t>
+              <a:t>Automated Cross-District Inventory Balancing &amp; Logistics</a:t>
             </a:r>
           </a:p>
         </p:txBody>
@@ -6568,7 +6795,7 @@
               </a:defRPr>
             </a:pPr>
             <a:r>
-              <a:t>Shared Predictive Power Without Centralizing Data</a:t>
+              <a:t>Eliminating Artificial Scarcity with Smart Routing</a:t>
             </a:r>
           </a:p>
           <a:p>
@@ -6580,29 +6807,29 @@
               </a:defRPr>
             </a:pPr>
             <a:r>
-              <a:t>• 100% DPDP Act 2023 Compliance: Sensitive patient health records and facility telemetry remain strictly inside state jurisdictional firewalls.</a:t>
+              <a:t>• Predictive Surge Lead-Time: ML forecasting detects impending stockouts 7 days in advance, activating transfers long before supplies hit zero.</a:t>
             </a:r>
             <a:br/>
             <a:br/>
             <a:r>
-              <a:t>• Local Model Training: State nodes (Maharashtra, Assam, Uttar Pradesh, Tamil Nadu) train localized forecasting models on regional seasonality and disease history.</a:t>
+              <a:t>• Surplus-to-Deficit Optimization: Identifies donor facilities with &gt;14 days excess buffer and matches them to clinics with ≤3 days critical stock.</a:t>
             </a:r>
             <a:br/>
             <a:br/>
             <a:r>
-              <a:t>• FedAvg Gradient Exchange: Only mathematical model weights are sent to the Central Sanjeevini Server for federated aggregation.</a:t>
+              <a:t>• Transit &amp; Cold-Chain Safeguards: Factors in road travel time, distance decay, and vaccine/oxytocin temperature sensitivity.</a:t>
             </a:r>
             <a:br/>
             <a:br/>
             <a:r>
-              <a:t>• 34.2% Higher Forecasting Accuracy: Small rural states benefit from national epidemiological intelligence without surrendering citizen data.</a:t>
+              <a:t>• One-Click Transfer Authorizations: Generates digital dispatch manifests, driver route coordinates, and receipt confirmations with full audit trails.</a:t>
             </a:r>
           </a:p>
         </p:txBody>
       </p:sp>
       <p:pic>
         <p:nvPicPr>
-          <p:cNvPr id="4" name="Picture 3" descr="federated.png"/>
+          <p:cNvPr id="4" name="Picture 3" descr="logistics.png"/>
           <p:cNvPicPr>
             <a:picLocks noChangeAspect="1"/>
           </p:cNvPicPr>
@@ -6654,7 +6881,7 @@
               </a:defRPr>
             </a:pPr>
             <a:r>
-              <a:t>Sanjeevini | National Health Resource &amp; Supply Chain Resilience Platform   •   Slide 8 of 10</a:t>
+              <a:t>Sanjeevini | National Health Resource &amp; Supply Chain Resilience Platform   •   Slide 8 of 11</a:t>
             </a:r>
           </a:p>
         </p:txBody>
@@ -6710,7 +6937,7 @@
               </a:defRPr>
             </a:pPr>
             <a:r>
-              <a:t>EXTREME ENVIRONMENT RESILIENCE</a:t>
+              <a:t>FEDERATED LEARNING &amp; DPDP COMPLIANCE</a:t>
             </a:r>
           </a:p>
           <a:p>
@@ -6722,7 +6949,7 @@
               </a:defRPr>
             </a:pPr>
             <a:r>
-              <a:t>Frontline Mobile Simulator: Offline Queue &amp; Sync Mode</a:t>
+              <a:t>State Data Sovereignty via Federated Model Aggregation</a:t>
             </a:r>
           </a:p>
         </p:txBody>
@@ -6760,7 +6987,7 @@
               </a:defRPr>
             </a:pPr>
             <a:r>
-              <a:t>Engineered for Connectivity-Deprived Rural &amp; Tribal Belts</a:t>
+              <a:t>Shared Predictive Power Without Centralizing Data</a:t>
             </a:r>
           </a:p>
           <a:p>
@@ -6772,29 +6999,29 @@
               </a:defRPr>
             </a:pPr>
             <a:r>
-              <a:t>• Offline-First Architecture: In remote villages and disaster flood zones with zero cellular connectivity, health workers can log inventory adjustments, voice notes, and SOS emergencies.</a:t>
+              <a:t>• 100% DPDP Act 2023 Compliance: Sensitive patient health records and facility telemetry remain strictly inside state jurisdictional firewalls.</a:t>
             </a:r>
             <a:br/>
             <a:br/>
             <a:r>
-              <a:t>• Local SQLite Transaction Queue: Data is committed safely to local offline storage with cryptographic timestamps.</a:t>
+              <a:t>• Local Model Training: State nodes (Maharashtra, Assam, Uttar Pradesh, Tamil Nadu) train localized forecasting models on regional seasonality and disease history.</a:t>
             </a:r>
             <a:br/>
             <a:br/>
             <a:r>
-              <a:t>• Automatic Cloud Synchronization: As soon as a 2G/3G/4G signal is detected, all queued updates seamlessly synchronize without data collision.</a:t>
+              <a:t>• FedAvg Gradient Exchange: Only mathematical model weights are sent to the Central Sanjeevini Server for federated aggregation.</a:t>
             </a:r>
             <a:br/>
             <a:br/>
             <a:r>
-              <a:t>• One-Touch Emergency SOS: Rapid distress trigger for critical anti-venom, oxygen, or maternal hemorrhage resuscitation.</a:t>
+              <a:t>• 34.2% Higher Forecasting Accuracy: Small rural states benefit from national epidemiological intelligence without surrendering citizen data.</a:t>
             </a:r>
           </a:p>
         </p:txBody>
       </p:sp>
       <p:pic>
         <p:nvPicPr>
-          <p:cNvPr id="4" name="Picture 3" descr="app_simulator.png"/>
+          <p:cNvPr id="4" name="Picture 3" descr="federated.png"/>
           <p:cNvPicPr>
             <a:picLocks noChangeAspect="1"/>
           </p:cNvPicPr>
@@ -6846,7 +7073,7 @@
               </a:defRPr>
             </a:pPr>
             <a:r>
-              <a:t>Sanjeevini | National Health Resource &amp; Supply Chain Resilience Platform   •   Slide 9 of 10</a:t>
+              <a:t>Sanjeevini | National Health Resource &amp; Supply Chain Resilience Platform   •   Slide 9 of 11</a:t>
             </a:r>
           </a:p>
         </p:txBody>

</xml_diff>

<commit_message>
docs(pitch-deck): update slides with app images in cols, remove carto references, update non-carto live map, and add multi-channel messaging
</commit_message>
<xml_diff>
--- a/Pitch-DECK/Sanjeevini-Pitch-Deck.pptx
+++ b/Pitch-DECK/Sanjeevini-Pitch-Deck.pptx
@@ -3246,7 +3246,7 @@
               </a:defRPr>
             </a:pPr>
             <a:r>
-              <a:t>• Google Cloud Run Scalable Ingestion  |  • Gemini 1.5 Flash Reasoning Engine  |  • CARTO GIS Surveillance  |  • Indic Voice AI (22 Indian Languages)  |  • Sovereign FedAvg Model Synthesis</a:t>
+              <a:t>• Google Cloud Run Scalable Ingestion  |  • Gemini 1.5 Flash Reasoning Engine  |  • GIS Engines  |  • Indic Voice AI (22 Indian Languages)  |  • Sovereign FedAvg Model Synthesis</a:t>
             </a:r>
           </a:p>
         </p:txBody>
@@ -3349,7 +3349,7 @@
               </a:defRPr>
             </a:pPr>
             <a:r>
-              <a:t>Frontline Mobile Simulator: Offline Queue &amp; Sync Mode</a:t>
+              <a:t>Frontline Mobile Simulator: Offline Queue &amp; Multi-Channel Sync</a:t>
             </a:r>
           </a:p>
         </p:txBody>
@@ -3392,7 +3392,7 @@
           </a:p>
           <a:p>
             <a:pPr>
-              <a:defRPr sz="1100">
+              <a:defRPr sz="1050">
                 <a:solidFill>
                   <a:srgbClr val="0F172A"/>
                 </a:solidFill>
@@ -3409,12 +3409,12 @@
             <a:br/>
             <a:br/>
             <a:r>
-              <a:t>• Automatic Cloud Synchronization: As soon as a 2G/3G/4G signal is detected, all queued updates seamlessly synchronize without data collision.</a:t>
+              <a:t>• Multi-Channel Support (SMS / WhatsApp / Telegram): Full emergency fallback allowing frontline health workers to report stockouts and receive SOS transfer confirmations via lightweight SMS, WhatsApp bots, and Telegram channels even without high-speed data.</a:t>
             </a:r>
             <a:br/>
             <a:br/>
             <a:r>
-              <a:t>• One-Touch Emergency SOS: Rapid distress trigger for critical anti-venom, oxygen, or maternal hemorrhage resuscitation.</a:t>
+              <a:t>• One-Touch Emergency SOS: Rapid priority distress trigger for Anti-Snake Venom, blood units, or maternal hemorrhage resuscitation.</a:t>
             </a:r>
           </a:p>
         </p:txBody>
@@ -3555,7 +3555,7 @@
         <p:spPr>
           <a:xfrm>
             <a:off x="731520" y="1371600"/>
-            <a:ext cx="2468880" cy="1371600"/>
+            <a:ext cx="2468880" cy="1097280"/>
           </a:xfrm>
           <a:prstGeom prst="roundRect">
             <a:avLst/>
@@ -3599,8 +3599,8 @@
         </p:nvSpPr>
         <p:spPr>
           <a:xfrm>
-            <a:off x="868680" y="1463040"/>
-            <a:ext cx="2194560" cy="1188720"/>
+            <a:off x="868680" y="1417320"/>
+            <a:ext cx="2194560" cy="1005840"/>
           </a:xfrm>
           <a:prstGeom prst="rect">
             <a:avLst/>
@@ -3615,9 +3615,9 @@
           <a:p>
             <a:pPr>
               <a:spcAft>
-                <a:spcPts val="400"/>
+                <a:spcPts val="200"/>
               </a:spcAft>
-              <a:defRPr b="1" sz="1100">
+              <a:defRPr b="1" sz="1000">
                 <a:solidFill>
                   <a:srgbClr val="059669"/>
                 </a:solidFill>
@@ -3629,7 +3629,7 @@
           </a:p>
           <a:p>
             <a:pPr>
-              <a:defRPr b="1" sz="1300">
+              <a:defRPr b="1" sz="1200">
                 <a:solidFill>
                   <a:srgbClr val="0F172A"/>
                 </a:solidFill>
@@ -3650,7 +3650,7 @@
         <p:spPr>
           <a:xfrm>
             <a:off x="3456432" y="1371600"/>
-            <a:ext cx="2468880" cy="1371600"/>
+            <a:ext cx="2468880" cy="1097280"/>
           </a:xfrm>
           <a:prstGeom prst="roundRect">
             <a:avLst/>
@@ -3694,8 +3694,8 @@
         </p:nvSpPr>
         <p:spPr>
           <a:xfrm>
-            <a:off x="3593592" y="1463040"/>
-            <a:ext cx="2194560" cy="1188720"/>
+            <a:off x="3593592" y="1417320"/>
+            <a:ext cx="2194560" cy="1005840"/>
           </a:xfrm>
           <a:prstGeom prst="rect">
             <a:avLst/>
@@ -3710,9 +3710,9 @@
           <a:p>
             <a:pPr>
               <a:spcAft>
-                <a:spcPts val="400"/>
+                <a:spcPts val="200"/>
               </a:spcAft>
-              <a:defRPr b="1" sz="1100">
+              <a:defRPr b="1" sz="1000">
                 <a:solidFill>
                   <a:srgbClr val="DC2626"/>
                 </a:solidFill>
@@ -3724,7 +3724,7 @@
           </a:p>
           <a:p>
             <a:pPr>
-              <a:defRPr b="1" sz="1300">
+              <a:defRPr b="1" sz="1200">
                 <a:solidFill>
                   <a:srgbClr val="0F172A"/>
                 </a:solidFill>
@@ -3745,7 +3745,7 @@
         <p:spPr>
           <a:xfrm>
             <a:off x="6181344" y="1371600"/>
-            <a:ext cx="2468880" cy="1371600"/>
+            <a:ext cx="2468880" cy="1097280"/>
           </a:xfrm>
           <a:prstGeom prst="roundRect">
             <a:avLst/>
@@ -3789,8 +3789,8 @@
         </p:nvSpPr>
         <p:spPr>
           <a:xfrm>
-            <a:off x="6318504" y="1463040"/>
-            <a:ext cx="2194560" cy="1188720"/>
+            <a:off x="6318504" y="1417320"/>
+            <a:ext cx="2194560" cy="1005840"/>
           </a:xfrm>
           <a:prstGeom prst="rect">
             <a:avLst/>
@@ -3805,9 +3805,9 @@
           <a:p>
             <a:pPr>
               <a:spcAft>
-                <a:spcPts val="400"/>
+                <a:spcPts val="200"/>
               </a:spcAft>
-              <a:defRPr b="1" sz="1100">
+              <a:defRPr b="1" sz="1000">
                 <a:solidFill>
                   <a:srgbClr val="1E40AF"/>
                 </a:solidFill>
@@ -3819,7 +3819,7 @@
           </a:p>
           <a:p>
             <a:pPr>
-              <a:defRPr b="1" sz="1300">
+              <a:defRPr b="1" sz="1200">
                 <a:solidFill>
                   <a:srgbClr val="0F172A"/>
                 </a:solidFill>
@@ -3840,7 +3840,7 @@
         <p:spPr>
           <a:xfrm>
             <a:off x="8906256" y="1371600"/>
-            <a:ext cx="2468880" cy="1371600"/>
+            <a:ext cx="2468880" cy="1097280"/>
           </a:xfrm>
           <a:prstGeom prst="roundRect">
             <a:avLst/>
@@ -3884,8 +3884,8 @@
         </p:nvSpPr>
         <p:spPr>
           <a:xfrm>
-            <a:off x="9043416" y="1463040"/>
-            <a:ext cx="2194560" cy="1188720"/>
+            <a:off x="9043416" y="1417320"/>
+            <a:ext cx="2194560" cy="1005840"/>
           </a:xfrm>
           <a:prstGeom prst="rect">
             <a:avLst/>
@@ -3900,9 +3900,9 @@
           <a:p>
             <a:pPr>
               <a:spcAft>
-                <a:spcPts val="400"/>
+                <a:spcPts val="200"/>
               </a:spcAft>
-              <a:defRPr b="1" sz="1100">
+              <a:defRPr b="1" sz="1000">
                 <a:solidFill>
                   <a:srgbClr val="D97706"/>
                 </a:solidFill>
@@ -3914,7 +3914,7 @@
           </a:p>
           <a:p>
             <a:pPr>
-              <a:defRPr b="1" sz="1300">
+              <a:defRPr b="1" sz="1200">
                 <a:solidFill>
                   <a:srgbClr val="0F172A"/>
                 </a:solidFill>
@@ -3934,8 +3934,8 @@
         </p:nvSpPr>
         <p:spPr>
           <a:xfrm>
-            <a:off x="731520" y="2926080"/>
-            <a:ext cx="3337560" cy="2103120"/>
+            <a:off x="731520" y="2606040"/>
+            <a:ext cx="3337560" cy="2651760"/>
           </a:xfrm>
           <a:prstGeom prst="roundRect">
             <a:avLst/>
@@ -3979,8 +3979,8 @@
         </p:nvSpPr>
         <p:spPr>
           <a:xfrm>
-            <a:off x="896112" y="3017520"/>
-            <a:ext cx="3008376" cy="1920240"/>
+            <a:off x="868680" y="2697480"/>
+            <a:ext cx="3063240" cy="1280160"/>
           </a:xfrm>
           <a:prstGeom prst="rect">
             <a:avLst/>
@@ -3995,24 +3995,24 @@
           <a:p>
             <a:pPr>
               <a:spcAft>
+                <a:spcPts val="200"/>
+              </a:spcAft>
+              <a:defRPr b="1" sz="900">
+                <a:solidFill>
+                  <a:srgbClr val="059669"/>
+                </a:solidFill>
+              </a:defRPr>
+            </a:pPr>
+            <a:r>
+              <a:t>PHASE 1 (MONTHS 0-3)</a:t>
+            </a:r>
+          </a:p>
+          <a:p>
+            <a:pPr>
+              <a:spcAft>
                 <a:spcPts val="400"/>
               </a:spcAft>
-              <a:defRPr b="1" sz="950">
-                <a:solidFill>
-                  <a:srgbClr val="059669"/>
-                </a:solidFill>
-              </a:defRPr>
-            </a:pPr>
-            <a:r>
-              <a:t>PHASE 1 (MONTHS 0-3)</a:t>
-            </a:r>
-          </a:p>
-          <a:p>
-            <a:pPr>
-              <a:spcAft>
-                <a:spcPts val="600"/>
-              </a:spcAft>
-              <a:defRPr b="1" sz="1200">
+              <a:defRPr b="1" sz="1100">
                 <a:solidFill>
                   <a:srgbClr val="0F172A"/>
                 </a:solidFill>
@@ -4024,7 +4024,7 @@
           </a:p>
           <a:p>
             <a:pPr>
-              <a:defRPr sz="950">
+              <a:defRPr sz="850">
                 <a:solidFill>
                   <a:srgbClr val="0F172A"/>
                 </a:solidFill>
@@ -4035,25 +4035,49 @@
             </a:r>
             <a:br/>
             <a:r>
-              <a:t>• Onboard 2,500 frontline ASHA/ANM workers with Indic voice assistant.</a:t>
+              <a:t>• Onboard 2,500 ASHA/ANM workers with Indic voice.</a:t>
             </a:r>
             <a:br/>
             <a:r>
-              <a:t>• Benchmark stockout reductions during active monsoon flood season.</a:t>
-            </a:r>
-          </a:p>
-        </p:txBody>
-      </p:sp>
-      <p:sp>
-        <p:nvSpPr>
-          <p:cNvPr id="13" name="Rounded Rectangle 12"/>
+              <a:t>• Benchmark stockout reductions during monsoon.</a:t>
+            </a:r>
+          </a:p>
+        </p:txBody>
+      </p:sp>
+      <p:pic>
+        <p:nvPicPr>
+          <p:cNvPr id="13" name="Picture 12" descr="p11_phase1.png"/>
+          <p:cNvPicPr>
+            <a:picLocks noChangeAspect="1"/>
+          </p:cNvPicPr>
+          <p:nvPr/>
+        </p:nvPicPr>
+        <p:blipFill>
+          <a:blip r:embed="rId2"/>
+          <a:stretch>
+            <a:fillRect/>
+          </a:stretch>
+        </p:blipFill>
+        <p:spPr>
+          <a:xfrm>
+            <a:off x="868680" y="4114800"/>
+            <a:ext cx="3063240" cy="2976237"/>
+          </a:xfrm>
+          <a:prstGeom prst="rect">
+            <a:avLst/>
+          </a:prstGeom>
+        </p:spPr>
+      </p:pic>
+      <p:sp>
+        <p:nvSpPr>
+          <p:cNvPr id="14" name="Rounded Rectangle 13"/>
           <p:cNvSpPr/>
           <p:nvPr/>
         </p:nvSpPr>
         <p:spPr>
           <a:xfrm>
-            <a:off x="4370832" y="2926080"/>
-            <a:ext cx="3337560" cy="2103120"/>
+            <a:off x="4370832" y="2606040"/>
+            <a:ext cx="3337560" cy="2651760"/>
           </a:xfrm>
           <a:prstGeom prst="roundRect">
             <a:avLst/>
@@ -4091,14 +4115,14 @@
       </p:sp>
       <p:sp>
         <p:nvSpPr>
-          <p:cNvPr id="14" name="TextBox 13"/>
+          <p:cNvPr id="15" name="TextBox 14"/>
           <p:cNvSpPr txBox="1"/>
           <p:nvPr/>
         </p:nvSpPr>
         <p:spPr>
           <a:xfrm>
-            <a:off x="4535424" y="3017520"/>
-            <a:ext cx="3008376" cy="1920240"/>
+            <a:off x="4507992" y="2697480"/>
+            <a:ext cx="3063240" cy="1280160"/>
           </a:xfrm>
           <a:prstGeom prst="rect">
             <a:avLst/>
@@ -4113,65 +4137,89 @@
           <a:p>
             <a:pPr>
               <a:spcAft>
+                <a:spcPts val="200"/>
+              </a:spcAft>
+              <a:defRPr b="1" sz="900">
+                <a:solidFill>
+                  <a:srgbClr val="1E40AF"/>
+                </a:solidFill>
+              </a:defRPr>
+            </a:pPr>
+            <a:r>
+              <a:t>PHASE 2 (MONTHS 3-9)</a:t>
+            </a:r>
+          </a:p>
+          <a:p>
+            <a:pPr>
+              <a:spcAft>
                 <a:spcPts val="400"/>
               </a:spcAft>
-              <a:defRPr b="1" sz="950">
-                <a:solidFill>
-                  <a:srgbClr val="1E40AF"/>
-                </a:solidFill>
-              </a:defRPr>
-            </a:pPr>
-            <a:r>
-              <a:t>PHASE 2 (MONTHS 3-9)</a:t>
-            </a:r>
-          </a:p>
-          <a:p>
-            <a:pPr>
-              <a:spcAft>
-                <a:spcPts val="600"/>
-              </a:spcAft>
-              <a:defRPr b="1" sz="1200">
+              <a:defRPr b="1" sz="1100">
                 <a:solidFill>
                   <a:srgbClr val="0F172A"/>
                 </a:solidFill>
               </a:defRPr>
             </a:pPr>
             <a:r>
-              <a:t>Statewide Cluster Federated Rollout</a:t>
-            </a:r>
-          </a:p>
-          <a:p>
-            <a:pPr>
-              <a:defRPr sz="950">
+              <a:t>Statewide Cluster Rollout</a:t>
+            </a:r>
+          </a:p>
+          <a:p>
+            <a:pPr>
+              <a:defRPr sz="850">
                 <a:solidFill>
                   <a:srgbClr val="0F172A"/>
                 </a:solidFill>
               </a:defRPr>
             </a:pPr>
             <a:r>
-              <a:t>• Expand to 4 regional state health directorates with active federated nodes.</a:t>
+              <a:t>• Expand to 4 regional state health directorates.</a:t>
             </a:r>
             <a:br/>
             <a:r>
-              <a:t>• Connect district cold-chain logistics hubs to redistribution engine.</a:t>
+              <a:t>• Connect district cold-chain logistics hubs.</a:t>
             </a:r>
             <a:br/>
             <a:r>
-              <a:t>• Integrate Ayushman Bharat Digital Mission (ABDM) registries.</a:t>
-            </a:r>
-          </a:p>
-        </p:txBody>
-      </p:sp>
-      <p:sp>
-        <p:nvSpPr>
-          <p:cNvPr id="15" name="Rounded Rectangle 14"/>
+              <a:t>• Integrate Ayushman Bharat (ABDM) registries.</a:t>
+            </a:r>
+          </a:p>
+        </p:txBody>
+      </p:sp>
+      <p:pic>
+        <p:nvPicPr>
+          <p:cNvPr id="16" name="Picture 15" descr="p11_phase2.png"/>
+          <p:cNvPicPr>
+            <a:picLocks noChangeAspect="1"/>
+          </p:cNvPicPr>
+          <p:nvPr/>
+        </p:nvPicPr>
+        <p:blipFill>
+          <a:blip r:embed="rId3"/>
+          <a:stretch>
+            <a:fillRect/>
+          </a:stretch>
+        </p:blipFill>
+        <p:spPr>
+          <a:xfrm>
+            <a:off x="4507992" y="4114800"/>
+            <a:ext cx="3063240" cy="824309"/>
+          </a:xfrm>
+          <a:prstGeom prst="rect">
+            <a:avLst/>
+          </a:prstGeom>
+        </p:spPr>
+      </p:pic>
+      <p:sp>
+        <p:nvSpPr>
+          <p:cNvPr id="17" name="Rounded Rectangle 16"/>
           <p:cNvSpPr/>
           <p:nvPr/>
         </p:nvSpPr>
         <p:spPr>
           <a:xfrm>
-            <a:off x="8010144" y="2926080"/>
-            <a:ext cx="3337560" cy="2103120"/>
+            <a:off x="8010144" y="2606040"/>
+            <a:ext cx="3337560" cy="2651760"/>
           </a:xfrm>
           <a:prstGeom prst="roundRect">
             <a:avLst/>
@@ -4209,14 +4257,14 @@
       </p:sp>
       <p:sp>
         <p:nvSpPr>
-          <p:cNvPr id="16" name="TextBox 15"/>
+          <p:cNvPr id="18" name="TextBox 17"/>
           <p:cNvSpPr txBox="1"/>
           <p:nvPr/>
         </p:nvSpPr>
         <p:spPr>
           <a:xfrm>
-            <a:off x="8174736" y="3017520"/>
-            <a:ext cx="3008376" cy="1920240"/>
+            <a:off x="8147304" y="2697480"/>
+            <a:ext cx="3063240" cy="1280160"/>
           </a:xfrm>
           <a:prstGeom prst="rect">
             <a:avLst/>
@@ -4231,65 +4279,89 @@
           <a:p>
             <a:pPr>
               <a:spcAft>
+                <a:spcPts val="200"/>
+              </a:spcAft>
+              <a:defRPr b="1" sz="900">
+                <a:solidFill>
+                  <a:srgbClr val="D97706"/>
+                </a:solidFill>
+              </a:defRPr>
+            </a:pPr>
+            <a:r>
+              <a:t>PHASE 3 (MONTHS 9-18)</a:t>
+            </a:r>
+          </a:p>
+          <a:p>
+            <a:pPr>
+              <a:spcAft>
                 <a:spcPts val="400"/>
               </a:spcAft>
-              <a:defRPr b="1" sz="950">
-                <a:solidFill>
-                  <a:srgbClr val="D97706"/>
-                </a:solidFill>
-              </a:defRPr>
-            </a:pPr>
-            <a:r>
-              <a:t>PHASE 3 (MONTHS 9-18)</a:t>
-            </a:r>
-          </a:p>
-          <a:p>
-            <a:pPr>
-              <a:spcAft>
-                <a:spcPts val="600"/>
-              </a:spcAft>
-              <a:defRPr b="1" sz="1200">
+              <a:defRPr b="1" sz="1100">
                 <a:solidFill>
                   <a:srgbClr val="0F172A"/>
                 </a:solidFill>
               </a:defRPr>
             </a:pPr>
             <a:r>
-              <a:t>Pan-India National Integration</a:t>
-            </a:r>
-          </a:p>
-          <a:p>
-            <a:pPr>
-              <a:defRPr sz="950">
+              <a:t>Pan-India Integration</a:t>
+            </a:r>
+          </a:p>
+          <a:p>
+            <a:pPr>
+              <a:defRPr sz="850">
                 <a:solidFill>
                   <a:srgbClr val="0F172A"/>
                 </a:solidFill>
               </a:defRPr>
             </a:pPr>
             <a:r>
-              <a:t>• Full deployment across all 31,000+ PHCs and 150,000+ Sub-Centres.</a:t>
+              <a:t>• Full deployment across all 31,000+ PHCs.</a:t>
             </a:r>
             <a:br/>
             <a:r>
-              <a:t>• Universal sovereign federated predictive intelligence.</a:t>
+              <a:t>• Universal sovereign federated predictive AI.</a:t>
             </a:r>
             <a:br/>
             <a:r>
-              <a:t>• Real-time national resilience safeguarding all 1.4 billion citizens.</a:t>
-            </a:r>
-          </a:p>
-        </p:txBody>
-      </p:sp>
-      <p:sp>
-        <p:nvSpPr>
-          <p:cNvPr id="17" name="Rounded Rectangle 16"/>
+              <a:t>• Real-time national resilience for 1.4B citizens.</a:t>
+            </a:r>
+          </a:p>
+        </p:txBody>
+      </p:sp>
+      <p:pic>
+        <p:nvPicPr>
+          <p:cNvPr id="19" name="Picture 18" descr="p11_phase3.png"/>
+          <p:cNvPicPr>
+            <a:picLocks noChangeAspect="1"/>
+          </p:cNvPicPr>
+          <p:nvPr/>
+        </p:nvPicPr>
+        <p:blipFill>
+          <a:blip r:embed="rId4"/>
+          <a:stretch>
+            <a:fillRect/>
+          </a:stretch>
+        </p:blipFill>
+        <p:spPr>
+          <a:xfrm>
+            <a:off x="8147304" y="4114800"/>
+            <a:ext cx="3063240" cy="861536"/>
+          </a:xfrm>
+          <a:prstGeom prst="rect">
+            <a:avLst/>
+          </a:prstGeom>
+        </p:spPr>
+      </p:pic>
+      <p:sp>
+        <p:nvSpPr>
+          <p:cNvPr id="20" name="Rounded Rectangle 19"/>
           <p:cNvSpPr/>
           <p:nvPr/>
         </p:nvSpPr>
         <p:spPr>
           <a:xfrm>
-            <a:off x="731520" y="5257800"/>
-            <a:ext cx="10728655" cy="1005840"/>
+            <a:off x="731520" y="5440680"/>
+            <a:ext cx="10728655" cy="868680"/>
           </a:xfrm>
           <a:prstGeom prst="roundRect">
             <a:avLst/>
@@ -4327,14 +4399,14 @@
       </p:sp>
       <p:sp>
         <p:nvSpPr>
-          <p:cNvPr id="18" name="TextBox 17"/>
+          <p:cNvPr id="21" name="TextBox 20"/>
           <p:cNvSpPr txBox="1"/>
           <p:nvPr/>
         </p:nvSpPr>
         <p:spPr>
           <a:xfrm>
-            <a:off x="914400" y="5349240"/>
-            <a:ext cx="10362895" cy="822960"/>
+            <a:off x="914400" y="5504688"/>
+            <a:ext cx="10362895" cy="731520"/>
           </a:xfrm>
           <a:prstGeom prst="rect">
             <a:avLst/>
@@ -4351,7 +4423,7 @@
               <a:spcAft>
                 <a:spcPts val="200"/>
               </a:spcAft>
-              <a:defRPr b="1" sz="1000">
+              <a:defRPr b="1" sz="950">
                 <a:solidFill>
                   <a:srgbClr val="059669"/>
                 </a:solidFill>
@@ -4363,7 +4435,7 @@
           </a:p>
           <a:p>
             <a:pPr>
-              <a:defRPr b="1" sz="1400">
+              <a:defRPr b="1" sz="1300">
                 <a:solidFill>
                   <a:srgbClr val="0F172A"/>
                 </a:solidFill>
@@ -4377,7 +4449,7 @@
       </p:sp>
       <p:sp>
         <p:nvSpPr>
-          <p:cNvPr id="19" name="TextBox 18"/>
+          <p:cNvPr id="22" name="TextBox 21"/>
           <p:cNvSpPr txBox="1"/>
           <p:nvPr/>
         </p:nvSpPr>
@@ -4461,7 +4533,7 @@
               </a:defRPr>
             </a:pPr>
             <a:r>
-              <a:t>THE CHALLENGE &amp; PROBLEM STATEMENT</a:t>
+              <a:t>THE CHALLENGE &amp; PUBLIC HEALTH CRISIS</a:t>
             </a:r>
           </a:p>
           <a:p>
@@ -4486,8 +4558,8 @@
         </p:nvSpPr>
         <p:spPr>
           <a:xfrm>
-            <a:off x="731520" y="1463040"/>
-            <a:ext cx="3337560" cy="4389120"/>
+            <a:off x="731520" y="1371600"/>
+            <a:ext cx="3337560" cy="4663440"/>
           </a:xfrm>
           <a:prstGeom prst="roundRect">
             <a:avLst/>
@@ -4531,8 +4603,8 @@
         </p:nvSpPr>
         <p:spPr>
           <a:xfrm>
-            <a:off x="914400" y="1645920"/>
-            <a:ext cx="2971800" cy="3931920"/>
+            <a:off x="914400" y="1508760"/>
+            <a:ext cx="2971800" cy="2377440"/>
           </a:xfrm>
           <a:prstGeom prst="rect">
             <a:avLst/>
@@ -4547,62 +4619,85 @@
           <a:p>
             <a:pPr>
               <a:spcAft>
-                <a:spcPts val="1200"/>
+                <a:spcPts val="400"/>
               </a:spcAft>
-              <a:defRPr b="1" sz="1200">
+              <a:defRPr b="1" sz="1100">
                 <a:solidFill>
                   <a:srgbClr val="DC2626"/>
                 </a:solidFill>
               </a:defRPr>
             </a:pPr>
             <a:r>
-              <a:t>42% RECURRENT STOCKOUTS</a:t>
+              <a:t>42% RECURRENT DEFICITS</a:t>
             </a:r>
           </a:p>
           <a:p>
             <a:pPr>
               <a:spcAft>
-                <a:spcPts val="1000"/>
+                <a:spcPts val="800"/>
               </a:spcAft>
-              <a:defRPr b="1" sz="1600">
+              <a:defRPr b="1" sz="1500">
                 <a:solidFill>
                   <a:srgbClr val="0F172A"/>
                 </a:solidFill>
               </a:defRPr>
             </a:pPr>
             <a:r>
-              <a:t>Chronic Medicine Invisibility</a:t>
-            </a:r>
-          </a:p>
-          <a:p>
-            <a:pPr>
-              <a:defRPr sz="1100">
+              <a:t>Chronic Medicine Stock-Outs</a:t>
+            </a:r>
+          </a:p>
+          <a:p>
+            <a:pPr>
+              <a:defRPr sz="950">
                 <a:solidFill>
                   <a:srgbClr val="0F172A"/>
                 </a:solidFill>
               </a:defRPr>
             </a:pPr>
             <a:r>
-              <a:t>• Crucial supplies (Paracetamol, ORS, Anti-Snake Venom, Oxytocin) run out during acute outbreaks with zero automated warning.</a:t>
+              <a:t>• Zero Automated Surge Warnings: Essential emergency drugs (Paracetamol, ORS, Anti-Snake Venom, Oxytocin) run out during acute outbreaks.</a:t>
             </a:r>
             <a:br/>
-            <a:br/>
-            <a:r>
-              <a:t>• The Paradox: Excess inventory frequently expires in district warehouses just 40km away while rural sub-centres turn away critically ill patients.</a:t>
-            </a:r>
-          </a:p>
-        </p:txBody>
-      </p:sp>
-      <p:sp>
-        <p:nvSpPr>
-          <p:cNvPr id="5" name="Rounded Rectangle 4"/>
+            <a:r>
+              <a:t>• The Proximity Paradox: Excess inventory expires in central district warehouses just 40km away while rural sub-centres turn away critical patients.</a:t>
+            </a:r>
+          </a:p>
+        </p:txBody>
+      </p:sp>
+      <p:pic>
+        <p:nvPicPr>
+          <p:cNvPr id="5" name="Picture 4" descr="p2_col1_stockout.png"/>
+          <p:cNvPicPr>
+            <a:picLocks noChangeAspect="1"/>
+          </p:cNvPicPr>
+          <p:nvPr/>
+        </p:nvPicPr>
+        <p:blipFill>
+          <a:blip r:embed="rId2"/>
+          <a:stretch>
+            <a:fillRect/>
+          </a:stretch>
+        </p:blipFill>
+        <p:spPr>
+          <a:xfrm>
+            <a:off x="914400" y="4114800"/>
+            <a:ext cx="2971800" cy="1062763"/>
+          </a:xfrm>
+          <a:prstGeom prst="rect">
+            <a:avLst/>
+          </a:prstGeom>
+        </p:spPr>
+      </p:pic>
+      <p:sp>
+        <p:nvSpPr>
+          <p:cNvPr id="6" name="Rounded Rectangle 5"/>
           <p:cNvSpPr/>
           <p:nvPr/>
         </p:nvSpPr>
         <p:spPr>
           <a:xfrm>
-            <a:off x="4434840" y="1463040"/>
-            <a:ext cx="3337560" cy="4389120"/>
+            <a:off x="4434840" y="1371600"/>
+            <a:ext cx="3337560" cy="4663440"/>
           </a:xfrm>
           <a:prstGeom prst="roundRect">
             <a:avLst/>
@@ -4640,14 +4735,14 @@
       </p:sp>
       <p:sp>
         <p:nvSpPr>
-          <p:cNvPr id="6" name="TextBox 5"/>
+          <p:cNvPr id="7" name="TextBox 6"/>
           <p:cNvSpPr txBox="1"/>
           <p:nvPr/>
         </p:nvSpPr>
         <p:spPr>
           <a:xfrm>
-            <a:off x="4617720" y="1645920"/>
-            <a:ext cx="2971800" cy="3931920"/>
+            <a:off x="4617720" y="1508760"/>
+            <a:ext cx="2971800" cy="2377440"/>
           </a:xfrm>
           <a:prstGeom prst="rect">
             <a:avLst/>
@@ -4662,9 +4757,9 @@
           <a:p>
             <a:pPr>
               <a:spcAft>
-                <a:spcPts val="1200"/>
+                <a:spcPts val="400"/>
               </a:spcAft>
-              <a:defRPr b="1" sz="1200">
+              <a:defRPr b="1" sz="1100">
                 <a:solidFill>
                   <a:srgbClr val="D97706"/>
                 </a:solidFill>
@@ -4677,47 +4772,70 @@
           <a:p>
             <a:pPr>
               <a:spcAft>
-                <a:spcPts val="1000"/>
+                <a:spcPts val="800"/>
               </a:spcAft>
-              <a:defRPr b="1" sz="1600">
+              <a:defRPr b="1" sz="1500">
                 <a:solidFill>
                   <a:srgbClr val="0F172A"/>
                 </a:solidFill>
               </a:defRPr>
             </a:pPr>
             <a:r>
-              <a:t>Manual Registers &amp; Blindspots</a:t>
-            </a:r>
-          </a:p>
-          <a:p>
-            <a:pPr>
-              <a:defRPr sz="1100">
+              <a:t>Manual Ledgers &amp; Data Invisibility</a:t>
+            </a:r>
+          </a:p>
+          <a:p>
+            <a:pPr>
+              <a:defRPr sz="950">
                 <a:solidFill>
                   <a:srgbClr val="0F172A"/>
                 </a:solidFill>
               </a:defRPr>
             </a:pPr>
             <a:r>
-              <a:t>• Frontline ASHA and ANM cadres lose 2 to 3 hours every day manually handwriting physical registers.</a:t>
+              <a:t>• Frontline Cadre Burden: Over 1,000,000 ASHA and ANM healthcare workers lose 2 to 3 hours daily manually compiling paper ledgers.</a:t>
             </a:r>
             <a:br/>
-            <a:br/>
-            <a:r>
-              <a:t>• Legacy batch portals update only once a day; catastrophic surge signals during monsoons and epidemics remain hidden until stockpiles are completely exhausted.</a:t>
-            </a:r>
-          </a:p>
-        </p:txBody>
-      </p:sp>
-      <p:sp>
-        <p:nvSpPr>
-          <p:cNvPr id="7" name="Rounded Rectangle 6"/>
+            <a:r>
+              <a:t>• Latency Blindspots: Batch databases update once every 24 hours. Critical outbreak signals remain hidden until stockpiles are completely exhausted.</a:t>
+            </a:r>
+          </a:p>
+        </p:txBody>
+      </p:sp>
+      <p:pic>
+        <p:nvPicPr>
+          <p:cNvPr id="8" name="Picture 7" descr="p2_col2_ledger.png"/>
+          <p:cNvPicPr>
+            <a:picLocks noChangeAspect="1"/>
+          </p:cNvPicPr>
+          <p:nvPr/>
+        </p:nvPicPr>
+        <p:blipFill>
+          <a:blip r:embed="rId3"/>
+          <a:stretch>
+            <a:fillRect/>
+          </a:stretch>
+        </p:blipFill>
+        <p:spPr>
+          <a:xfrm>
+            <a:off x="4617720" y="4114800"/>
+            <a:ext cx="2971800" cy="1245129"/>
+          </a:xfrm>
+          <a:prstGeom prst="rect">
+            <a:avLst/>
+          </a:prstGeom>
+        </p:spPr>
+      </p:pic>
+      <p:sp>
+        <p:nvSpPr>
+          <p:cNvPr id="9" name="Rounded Rectangle 8"/>
           <p:cNvSpPr/>
           <p:nvPr/>
         </p:nvSpPr>
         <p:spPr>
           <a:xfrm>
-            <a:off x="8138160" y="1463040"/>
-            <a:ext cx="3337560" cy="4389120"/>
+            <a:off x="8138160" y="1371600"/>
+            <a:ext cx="3337560" cy="4663440"/>
           </a:xfrm>
           <a:prstGeom prst="roundRect">
             <a:avLst/>
@@ -4755,14 +4873,14 @@
       </p:sp>
       <p:sp>
         <p:nvSpPr>
-          <p:cNvPr id="8" name="TextBox 7"/>
+          <p:cNvPr id="10" name="TextBox 9"/>
           <p:cNvSpPr txBox="1"/>
           <p:nvPr/>
         </p:nvSpPr>
         <p:spPr>
           <a:xfrm>
-            <a:off x="8321040" y="1645920"/>
-            <a:ext cx="2971800" cy="3931920"/>
+            <a:off x="8321040" y="1508760"/>
+            <a:ext cx="2971800" cy="2377440"/>
           </a:xfrm>
           <a:prstGeom prst="rect">
             <a:avLst/>
@@ -4777,9 +4895,9 @@
           <a:p>
             <a:pPr>
               <a:spcAft>
-                <a:spcPts val="1200"/>
+                <a:spcPts val="400"/>
               </a:spcAft>
-              <a:defRPr b="1" sz="1200">
+              <a:defRPr b="1" sz="1100">
                 <a:solidFill>
                   <a:srgbClr val="1E40AF"/>
                 </a:solidFill>
@@ -4792,40 +4910,63 @@
           <a:p>
             <a:pPr>
               <a:spcAft>
-                <a:spcPts val="1000"/>
+                <a:spcPts val="800"/>
               </a:spcAft>
-              <a:defRPr b="1" sz="1600">
+              <a:defRPr b="1" sz="1500">
                 <a:solidFill>
                   <a:srgbClr val="0F172A"/>
                 </a:solidFill>
               </a:defRPr>
             </a:pPr>
             <a:r>
-              <a:t>Interstate Data Silos</a:t>
-            </a:r>
-          </a:p>
-          <a:p>
-            <a:pPr>
-              <a:defRPr sz="1100">
+              <a:t>Interstate Data Silos &amp; DPDP Friction</a:t>
+            </a:r>
+          </a:p>
+          <a:p>
+            <a:pPr>
+              <a:defRPr sz="950">
                 <a:solidFill>
                   <a:srgbClr val="0F172A"/>
                 </a:solidFill>
               </a:defRPr>
             </a:pPr>
             <a:r>
-              <a:t>• Under India's Digital Personal Data Protection (DPDP) Act 2023, patient health records cannot be moved into a monolithic central repository.</a:t>
+              <a:t>• Under India's DPDP Act 2023, patient health records cannot be moved into a monolithic central repository.</a:t>
             </a:r>
             <a:br/>
-            <a:br/>
-            <a:r>
-              <a:t>• As a result, states cannot share predictive epidemiology or coordinate cross-border mutual aid without risking privacy violations.</a:t>
-            </a:r>
-          </a:p>
-        </p:txBody>
-      </p:sp>
-      <p:sp>
-        <p:nvSpPr>
-          <p:cNvPr id="9" name="TextBox 8"/>
+            <a:r>
+              <a:t>• Isolated Prediction Models: States cannot share local epidemiological trends or coordinate cross-border emergency replenishment without severe privacy risks.</a:t>
+            </a:r>
+          </a:p>
+        </p:txBody>
+      </p:sp>
+      <p:pic>
+        <p:nvPicPr>
+          <p:cNvPr id="11" name="Picture 10" descr="p2_col3_silos.png"/>
+          <p:cNvPicPr>
+            <a:picLocks noChangeAspect="1"/>
+          </p:cNvPicPr>
+          <p:nvPr/>
+        </p:nvPicPr>
+        <p:blipFill>
+          <a:blip r:embed="rId4"/>
+          <a:stretch>
+            <a:fillRect/>
+          </a:stretch>
+        </p:blipFill>
+        <p:spPr>
+          <a:xfrm>
+            <a:off x="8321040" y="4114800"/>
+            <a:ext cx="2971800" cy="892572"/>
+          </a:xfrm>
+          <a:prstGeom prst="rect">
+            <a:avLst/>
+          </a:prstGeom>
+        </p:spPr>
+      </p:pic>
+      <p:sp>
+        <p:nvSpPr>
+          <p:cNvPr id="12" name="TextBox 11"/>
           <p:cNvSpPr txBox="1"/>
           <p:nvPr/>
         </p:nvSpPr>
@@ -4921,7 +5062,7 @@
               </a:defRPr>
             </a:pPr>
             <a:r>
-              <a:t>The Sanjeevini Ecosystem: 4 Pillars of Health Resilience</a:t>
+              <a:t>The Sanjeevini Ecosystem: 4 Pillars of National Resilience</a:t>
             </a:r>
           </a:p>
         </p:txBody>
@@ -4934,8 +5075,8 @@
         </p:nvSpPr>
         <p:spPr>
           <a:xfrm>
-            <a:off x="731520" y="1463040"/>
-            <a:ext cx="2468880" cy="4389120"/>
+            <a:off x="731520" y="1371600"/>
+            <a:ext cx="2468880" cy="4663440"/>
           </a:xfrm>
           <a:prstGeom prst="roundRect">
             <a:avLst/>
@@ -4979,8 +5120,8 @@
         </p:nvSpPr>
         <p:spPr>
           <a:xfrm>
-            <a:off x="896112" y="1645920"/>
-            <a:ext cx="2139696" cy="3931920"/>
+            <a:off x="868680" y="1508760"/>
+            <a:ext cx="2194560" cy="2286000"/>
           </a:xfrm>
           <a:prstGeom prst="rect">
             <a:avLst/>
@@ -4995,7 +5136,7 @@
           <a:p>
             <a:pPr>
               <a:spcAft>
-                <a:spcPts val="800"/>
+                <a:spcPts val="400"/>
               </a:spcAft>
               <a:defRPr b="1" sz="1000">
                 <a:solidFill>
@@ -5004,13 +5145,13 @@
               </a:defRPr>
             </a:pPr>
             <a:r>
-              <a:t>1. GROUND CAPTURE</a:t>
+              <a:t>PILLAR 1</a:t>
             </a:r>
           </a:p>
           <a:p>
             <a:pPr>
               <a:spcAft>
-                <a:spcPts val="1000"/>
+                <a:spcPts val="600"/>
               </a:spcAft>
               <a:defRPr b="1" sz="1400">
                 <a:solidFill>
@@ -5019,43 +5160,65 @@
               </a:defRPr>
             </a:pPr>
             <a:r>
-              <a:t>Multimodal Ingestion</a:t>
-            </a:r>
-          </a:p>
-          <a:p>
-            <a:pPr>
-              <a:defRPr sz="1050">
+              <a:t>Ground Capture</a:t>
+            </a:r>
+          </a:p>
+          <a:p>
+            <a:pPr>
+              <a:defRPr sz="950">
                 <a:solidFill>
                   <a:srgbClr val="0F172A"/>
                 </a:solidFill>
               </a:defRPr>
             </a:pPr>
             <a:r>
-              <a:t>• Indic Voice AI (22 scheduled Indian languages) for hands-free ASHA updates.</a:t>
+              <a:t>• Indic Voice AI (22 languages)</a:t>
             </a:r>
             <a:br/>
+            <a:r>
+              <a:t>• Gemini Vision OCR for ledgers</a:t>
+            </a:r>
             <a:br/>
             <a:r>
-              <a:t>• Gemini Vision OCR scans physical stock ledgers &amp; medicine blister packs with 98.7% accuracy.</a:t>
-            </a:r>
-            <a:br/>
-            <a:br/>
-            <a:r>
               <a:t>• Zero-paperwork field entry.</a:t>
             </a:r>
           </a:p>
         </p:txBody>
       </p:sp>
-      <p:sp>
-        <p:nvSpPr>
-          <p:cNvPr id="5" name="Rounded Rectangle 4"/>
+      <p:pic>
+        <p:nvPicPr>
+          <p:cNvPr id="5" name="Picture 4" descr="p3_col1_voice.png"/>
+          <p:cNvPicPr>
+            <a:picLocks noChangeAspect="1"/>
+          </p:cNvPicPr>
+          <p:nvPr/>
+        </p:nvPicPr>
+        <p:blipFill>
+          <a:blip r:embed="rId2"/>
+          <a:stretch>
+            <a:fillRect/>
+          </a:stretch>
+        </p:blipFill>
+        <p:spPr>
+          <a:xfrm>
+            <a:off x="868680" y="3931920"/>
+            <a:ext cx="2194560" cy="1009650"/>
+          </a:xfrm>
+          <a:prstGeom prst="rect">
+            <a:avLst/>
+          </a:prstGeom>
+        </p:spPr>
+      </p:pic>
+      <p:sp>
+        <p:nvSpPr>
+          <p:cNvPr id="6" name="Rounded Rectangle 5"/>
           <p:cNvSpPr/>
           <p:nvPr/>
         </p:nvSpPr>
         <p:spPr>
           <a:xfrm>
-            <a:off x="3456432" y="1463040"/>
-            <a:ext cx="2468880" cy="4389120"/>
+            <a:off x="3456432" y="1371600"/>
+            <a:ext cx="2468880" cy="4663440"/>
           </a:xfrm>
           <a:prstGeom prst="roundRect">
             <a:avLst/>
@@ -5093,14 +5256,14 @@
       </p:sp>
       <p:sp>
         <p:nvSpPr>
-          <p:cNvPr id="6" name="TextBox 5"/>
+          <p:cNvPr id="7" name="TextBox 6"/>
           <p:cNvSpPr txBox="1"/>
           <p:nvPr/>
         </p:nvSpPr>
         <p:spPr>
           <a:xfrm>
-            <a:off x="3621024" y="1645920"/>
-            <a:ext cx="2139696" cy="3931920"/>
+            <a:off x="3593592" y="1508760"/>
+            <a:ext cx="2194560" cy="2286000"/>
           </a:xfrm>
           <a:prstGeom prst="rect">
             <a:avLst/>
@@ -5115,7 +5278,7 @@
           <a:p>
             <a:pPr>
               <a:spcAft>
-                <a:spcPts val="800"/>
+                <a:spcPts val="400"/>
               </a:spcAft>
               <a:defRPr b="1" sz="1000">
                 <a:solidFill>
@@ -5124,13 +5287,13 @@
               </a:defRPr>
             </a:pPr>
             <a:r>
-              <a:t>2. GIS SURVEILLANCE</a:t>
+              <a:t>PILLAR 2</a:t>
             </a:r>
           </a:p>
           <a:p>
             <a:pPr>
               <a:spcAft>
-                <a:spcPts val="1000"/>
+                <a:spcPts val="600"/>
               </a:spcAft>
               <a:defRPr b="1" sz="1400">
                 <a:solidFill>
@@ -5139,55 +5302,65 @@
               </a:defRPr>
             </a:pPr>
             <a:r>
-              <a:t>Real-Time Resource Map</a:t>
-            </a:r>
-          </a:p>
-          <a:p>
-            <a:pPr>
-              <a:defRPr sz="1050">
+              <a:t>GIS Surveillance</a:t>
+            </a:r>
+          </a:p>
+          <a:p>
+            <a:pPr>
+              <a:defRPr sz="950">
                 <a:solidFill>
                   <a:srgbClr val="0F172A"/>
                 </a:solidFill>
               </a:defRPr>
             </a:pPr>
             <a:r>
-              <a:t>• Live tracking across 31,000+ PHCs.</a:t>
+              <a:t>• Live 31,000+ PHC tracking</a:t>
             </a:r>
             <a:br/>
+            <a:r>
+              <a:t>• High-precision GIS mapping</a:t>
+            </a:r>
             <a:br/>
             <a:r>
-              <a:t>• CARTO Positron + OSM + Google Maps dual engine.</a:t>
-            </a:r>
-            <a:br/>
-            <a:br/>
-            <a:r>
-              <a:t>• Dynamic buffer thresholds:</a:t>
-            </a:r>
-            <a:br/>
-            <a:r>
-              <a:t>  🟢 Stable (&gt;7 Days)</a:t>
-            </a:r>
-            <a:br/>
-            <a:r>
-              <a:t>  🟡 Warning (4-7 Days)</a:t>
-            </a:r>
-            <a:br/>
-            <a:r>
-              <a:t>  🔴 Critical Deficit (≤3 Days).</a:t>
-            </a:r>
-          </a:p>
-        </p:txBody>
-      </p:sp>
-      <p:sp>
-        <p:nvSpPr>
-          <p:cNvPr id="7" name="Rounded Rectangle 6"/>
+              <a:t>• Color-coded buffer thresholds.</a:t>
+            </a:r>
+          </a:p>
+        </p:txBody>
+      </p:sp>
+      <p:pic>
+        <p:nvPicPr>
+          <p:cNvPr id="8" name="Picture 7" descr="p3_col2_map.png"/>
+          <p:cNvPicPr>
+            <a:picLocks noChangeAspect="1"/>
+          </p:cNvPicPr>
+          <p:nvPr/>
+        </p:nvPicPr>
+        <p:blipFill>
+          <a:blip r:embed="rId3"/>
+          <a:stretch>
+            <a:fillRect/>
+          </a:stretch>
+        </p:blipFill>
+        <p:spPr>
+          <a:xfrm>
+            <a:off x="3593592" y="3931920"/>
+            <a:ext cx="2194560" cy="1316355"/>
+          </a:xfrm>
+          <a:prstGeom prst="rect">
+            <a:avLst/>
+          </a:prstGeom>
+        </p:spPr>
+      </p:pic>
+      <p:sp>
+        <p:nvSpPr>
+          <p:cNvPr id="9" name="Rounded Rectangle 8"/>
           <p:cNvSpPr/>
           <p:nvPr/>
         </p:nvSpPr>
         <p:spPr>
           <a:xfrm>
-            <a:off x="6181344" y="1463040"/>
-            <a:ext cx="2468880" cy="4389120"/>
+            <a:off x="6181344" y="1371600"/>
+            <a:ext cx="2468880" cy="4663440"/>
           </a:xfrm>
           <a:prstGeom prst="roundRect">
             <a:avLst/>
@@ -5225,14 +5398,14 @@
       </p:sp>
       <p:sp>
         <p:nvSpPr>
-          <p:cNvPr id="8" name="TextBox 7"/>
+          <p:cNvPr id="10" name="TextBox 9"/>
           <p:cNvSpPr txBox="1"/>
           <p:nvPr/>
         </p:nvSpPr>
         <p:spPr>
           <a:xfrm>
-            <a:off x="6345936" y="1645920"/>
-            <a:ext cx="2139696" cy="3931920"/>
+            <a:off x="6318504" y="1508760"/>
+            <a:ext cx="2194560" cy="2286000"/>
           </a:xfrm>
           <a:prstGeom prst="rect">
             <a:avLst/>
@@ -5247,7 +5420,7 @@
           <a:p>
             <a:pPr>
               <a:spcAft>
-                <a:spcPts val="800"/>
+                <a:spcPts val="400"/>
               </a:spcAft>
               <a:defRPr b="1" sz="1000">
                 <a:solidFill>
@@ -5256,13 +5429,13 @@
               </a:defRPr>
             </a:pPr>
             <a:r>
-              <a:t>3. PREDICTIVE LOGISTICS</a:t>
+              <a:t>PILLAR 3</a:t>
             </a:r>
           </a:p>
           <a:p>
             <a:pPr>
               <a:spcAft>
-                <a:spcPts val="1000"/>
+                <a:spcPts val="600"/>
               </a:spcAft>
               <a:defRPr b="1" sz="1400">
                 <a:solidFill>
@@ -5271,43 +5444,65 @@
               </a:defRPr>
             </a:pPr>
             <a:r>
-              <a:t>Cross-District Balancing</a:t>
-            </a:r>
-          </a:p>
-          <a:p>
-            <a:pPr>
-              <a:defRPr sz="1050">
+              <a:t>Predictive Logistics</a:t>
+            </a:r>
+          </a:p>
+          <a:p>
+            <a:pPr>
+              <a:defRPr sz="950">
                 <a:solidFill>
                   <a:srgbClr val="0F172A"/>
                 </a:solidFill>
               </a:defRPr>
             </a:pPr>
             <a:r>
-              <a:t>• ML models forecast disease surges 7 days prior to stockout.</a:t>
+              <a:t>• 7-Day surge early warnings</a:t>
             </a:r>
             <a:br/>
+            <a:r>
+              <a:t>• Automated surplus-deficit pairing</a:t>
+            </a:r>
             <a:br/>
             <a:r>
-              <a:t>• Automated algorithm matches donor clinics (&gt;14d stock) to deficit clinics (≤3d stock).</a:t>
-            </a:r>
-            <a:br/>
-            <a:br/>
-            <a:r>
-              <a:t>• Generates turnkey dispatch manifests with route optimization.</a:t>
-            </a:r>
-          </a:p>
-        </p:txBody>
-      </p:sp>
-      <p:sp>
-        <p:nvSpPr>
-          <p:cNvPr id="9" name="Rounded Rectangle 8"/>
+              <a:t>• Turnkey transfer e-Challans.</a:t>
+            </a:r>
+          </a:p>
+        </p:txBody>
+      </p:sp>
+      <p:pic>
+        <p:nvPicPr>
+          <p:cNvPr id="11" name="Picture 10" descr="p3_col3_logistics.png"/>
+          <p:cNvPicPr>
+            <a:picLocks noChangeAspect="1"/>
+          </p:cNvPicPr>
+          <p:nvPr/>
+        </p:nvPicPr>
+        <p:blipFill>
+          <a:blip r:embed="rId4"/>
+          <a:stretch>
+            <a:fillRect/>
+          </a:stretch>
+        </p:blipFill>
+        <p:spPr>
+          <a:xfrm>
+            <a:off x="6318504" y="3931920"/>
+            <a:ext cx="2194560" cy="685800"/>
+          </a:xfrm>
+          <a:prstGeom prst="rect">
+            <a:avLst/>
+          </a:prstGeom>
+        </p:spPr>
+      </p:pic>
+      <p:sp>
+        <p:nvSpPr>
+          <p:cNvPr id="12" name="Rounded Rectangle 11"/>
           <p:cNvSpPr/>
           <p:nvPr/>
         </p:nvSpPr>
         <p:spPr>
           <a:xfrm>
-            <a:off x="8906256" y="1463040"/>
-            <a:ext cx="2468880" cy="4389120"/>
+            <a:off x="8906256" y="1371600"/>
+            <a:ext cx="2468880" cy="4663440"/>
           </a:xfrm>
           <a:prstGeom prst="roundRect">
             <a:avLst/>
@@ -5345,14 +5540,14 @@
       </p:sp>
       <p:sp>
         <p:nvSpPr>
-          <p:cNvPr id="10" name="TextBox 9"/>
+          <p:cNvPr id="13" name="TextBox 12"/>
           <p:cNvSpPr txBox="1"/>
           <p:nvPr/>
         </p:nvSpPr>
         <p:spPr>
           <a:xfrm>
-            <a:off x="9070848" y="1645920"/>
-            <a:ext cx="2139696" cy="3931920"/>
+            <a:off x="9043416" y="1508760"/>
+            <a:ext cx="2194560" cy="2286000"/>
           </a:xfrm>
           <a:prstGeom prst="rect">
             <a:avLst/>
@@ -5367,7 +5562,7 @@
           <a:p>
             <a:pPr>
               <a:spcAft>
-                <a:spcPts val="800"/>
+                <a:spcPts val="400"/>
               </a:spcAft>
               <a:defRPr b="1" sz="1000">
                 <a:solidFill>
@@ -5376,13 +5571,13 @@
               </a:defRPr>
             </a:pPr>
             <a:r>
-              <a:t>4. FEDERATED AI</a:t>
+              <a:t>PILLAR 4</a:t>
             </a:r>
           </a:p>
           <a:p>
             <a:pPr>
               <a:spcAft>
-                <a:spcPts val="1000"/>
+                <a:spcPts val="600"/>
               </a:spcAft>
               <a:defRPr b="1" sz="1400">
                 <a:solidFill>
@@ -5391,36 +5586,58 @@
               </a:defRPr>
             </a:pPr>
             <a:r>
-              <a:t>Sovereign Learning</a:t>
-            </a:r>
-          </a:p>
-          <a:p>
-            <a:pPr>
-              <a:defRPr sz="1050">
+              <a:t>Sovereign Federated AI</a:t>
+            </a:r>
+          </a:p>
+          <a:p>
+            <a:pPr>
+              <a:defRPr sz="950">
                 <a:solidFill>
                   <a:srgbClr val="0F172A"/>
                 </a:solidFill>
               </a:defRPr>
             </a:pPr>
             <a:r>
-              <a:t>• State health servers train local predictive models in-place.</a:t>
+              <a:t>• Local state training in-place</a:t>
             </a:r>
             <a:br/>
+            <a:r>
+              <a:t>• FedAvg weight aggregation</a:t>
+            </a:r>
             <a:br/>
             <a:r>
-              <a:t>• Only mathematical model gradients are aggregated centrally.</a:t>
-            </a:r>
-            <a:br/>
-            <a:br/>
-            <a:r>
-              <a:t>• Delivers +34.2% forecasting accuracy boost without sharing raw patient data.</a:t>
-            </a:r>
-          </a:p>
-        </p:txBody>
-      </p:sp>
-      <p:sp>
-        <p:nvSpPr>
-          <p:cNvPr id="11" name="TextBox 10"/>
+              <a:t>• +34.2% forecasting boost.</a:t>
+            </a:r>
+          </a:p>
+        </p:txBody>
+      </p:sp>
+      <p:pic>
+        <p:nvPicPr>
+          <p:cNvPr id="14" name="Picture 13" descr="p3_col4_federated.png"/>
+          <p:cNvPicPr>
+            <a:picLocks noChangeAspect="1"/>
+          </p:cNvPicPr>
+          <p:nvPr/>
+        </p:nvPicPr>
+        <p:blipFill>
+          <a:blip r:embed="rId5"/>
+          <a:stretch>
+            <a:fillRect/>
+          </a:stretch>
+        </p:blipFill>
+        <p:spPr>
+          <a:xfrm>
+            <a:off x="9043416" y="3931920"/>
+            <a:ext cx="2194560" cy="685800"/>
+          </a:xfrm>
+          <a:prstGeom prst="rect">
+            <a:avLst/>
+          </a:prstGeom>
+        </p:spPr>
+      </p:pic>
+      <p:sp>
+        <p:nvSpPr>
+          <p:cNvPr id="15" name="TextBox 14"/>
           <p:cNvSpPr txBox="1"/>
           <p:nvPr/>
         </p:nvSpPr>
@@ -5706,7 +5923,7 @@
               </a:defRPr>
             </a:pPr>
             <a:r>
-              <a:t>React 18 TypeScript Vite SPA  •  CARTO Positron &amp; Leaflet GIS Engine  •  22-Language Audio Processor  •  Camera / OCR Canvas Extractor</a:t>
+              <a:t>React 18 TypeScript Vite SPA  •  Leaflet &amp; Dual GIS Heatmap Engine  •  22-Language Audio Processor  •  Camera / OCR Canvas Extractor</a:t>
             </a:r>
           </a:p>
         </p:txBody>
@@ -6320,7 +6537,7 @@
               </a:defRPr>
             </a:pPr>
             <a:r>
-              <a:t>National Command Center &amp; High-Precision CARTO GIS Surveillance</a:t>
+              <a:t>National Command Center &amp; High-Precision GIS Surveillance</a:t>
             </a:r>
           </a:p>
         </p:txBody>
@@ -6395,7 +6612,7 @@
               </a:defRPr>
             </a:pPr>
             <a:r>
-              <a:t>Layer Support: CARTO Positron (Clean Light), CARTO Voyager, CARTO Dark Matter, OpenStreetMap, and Google Maps.</a:t>
+              <a:t>Layer Support: OpenStreetMap Standard, Google Maps Platform, and High-Performance GIS Layers.</a:t>
             </a:r>
           </a:p>
         </p:txBody>

</xml_diff>

<commit_message>
docs(pitch-deck): update slide 5 with rendered Mermaid system architecture block diagram and 3-tier architectural breakdown
</commit_message>
<xml_diff>
--- a/Pitch-DECK/Sanjeevini-Pitch-Deck.pptx
+++ b/Pitch-DECK/Sanjeevini-Pitch-Deck.pptx
@@ -6299,7 +6299,7 @@
               </a:defRPr>
             </a:pPr>
             <a:r>
-              <a:t>PIPELINE FLOW &amp; DATA TELEMETRY (README FLOWCHART)</a:t>
+              <a:t>ENTERPRISE BLOCK DIAGRAM &amp; DATA TELEMETRY</a:t>
             </a:r>
           </a:p>
           <a:p>
@@ -6316,46 +6316,22 @@
           </a:p>
         </p:txBody>
       </p:sp>
-      <p:pic>
-        <p:nvPicPr>
-          <p:cNvPr id="3" name="Picture 2" descr="system_architecture_diagram.png"/>
-          <p:cNvPicPr>
-            <a:picLocks noChangeAspect="1"/>
-          </p:cNvPicPr>
-          <p:nvPr/>
-        </p:nvPicPr>
-        <p:blipFill>
-          <a:blip r:embed="rId2"/>
-          <a:stretch>
-            <a:fillRect/>
-          </a:stretch>
-        </p:blipFill>
-        <p:spPr>
-          <a:xfrm>
-            <a:off x="731520" y="1371600"/>
-            <a:ext cx="10728655" cy="3792747"/>
-          </a:xfrm>
-          <a:prstGeom prst="rect">
-            <a:avLst/>
-          </a:prstGeom>
-        </p:spPr>
-      </p:pic>
-      <p:sp>
-        <p:nvSpPr>
-          <p:cNvPr id="4" name="Rounded Rectangle 3"/>
+      <p:sp>
+        <p:nvSpPr>
+          <p:cNvPr id="3" name="Rounded Rectangle 2"/>
           <p:cNvSpPr/>
           <p:nvPr/>
         </p:nvSpPr>
         <p:spPr>
           <a:xfrm>
-            <a:off x="731520" y="5303520"/>
-            <a:ext cx="10728655" cy="960120"/>
+            <a:off x="731520" y="1280160"/>
+            <a:ext cx="6035040" cy="5029200"/>
           </a:xfrm>
           <a:prstGeom prst="roundRect">
             <a:avLst/>
           </a:prstGeom>
           <a:solidFill>
-            <a:srgbClr val="F8FAFC"/>
+            <a:srgbClr val="FFFFFF"/>
           </a:solidFill>
           <a:ln w="12700">
             <a:solidFill>
@@ -6385,16 +6361,85 @@
           </a:p>
         </p:txBody>
       </p:sp>
-      <p:sp>
-        <p:nvSpPr>
-          <p:cNvPr id="5" name="TextBox 4"/>
+      <p:pic>
+        <p:nvPicPr>
+          <p:cNvPr id="4" name="Picture 3" descr="system_architecture_diagram.png"/>
+          <p:cNvPicPr>
+            <a:picLocks noChangeAspect="1"/>
+          </p:cNvPicPr>
+          <p:nvPr/>
+        </p:nvPicPr>
+        <p:blipFill>
+          <a:blip r:embed="rId2"/>
+          <a:stretch>
+            <a:fillRect/>
+          </a:stretch>
+        </p:blipFill>
+        <p:spPr>
+          <a:xfrm>
+            <a:off x="822960" y="1371600"/>
+            <a:ext cx="5852160" cy="4846320"/>
+          </a:xfrm>
+          <a:prstGeom prst="rect">
+            <a:avLst/>
+          </a:prstGeom>
+        </p:spPr>
+      </p:pic>
+      <p:sp>
+        <p:nvSpPr>
+          <p:cNvPr id="5" name="Rounded Rectangle 4"/>
+          <p:cNvSpPr/>
+          <p:nvPr/>
+        </p:nvSpPr>
+        <p:spPr>
+          <a:xfrm>
+            <a:off x="6949440" y="1280160"/>
+            <a:ext cx="4510735" cy="1536192"/>
+          </a:xfrm>
+          <a:prstGeom prst="roundRect">
+            <a:avLst/>
+          </a:prstGeom>
+          <a:solidFill>
+            <a:srgbClr val="EFF6FF"/>
+          </a:solidFill>
+          <a:ln w="12700">
+            <a:solidFill>
+              <a:srgbClr val="BFDBFE"/>
+            </a:solidFill>
+          </a:ln>
+        </p:spPr>
+        <p:style>
+          <a:lnRef idx="1">
+            <a:schemeClr val="accent1"/>
+          </a:lnRef>
+          <a:fillRef idx="3">
+            <a:schemeClr val="accent1"/>
+          </a:fillRef>
+          <a:effectRef idx="2">
+            <a:schemeClr val="accent1"/>
+          </a:effectRef>
+          <a:fontRef idx="minor">
+            <a:schemeClr val="lt1"/>
+          </a:fontRef>
+        </p:style>
+        <p:txBody>
+          <a:bodyPr rtlCol="0" anchor="ctr"/>
+          <a:lstStyle/>
+          <a:p>
+            <a:pPr algn="ctr"/>
+          </a:p>
+        </p:txBody>
+      </p:sp>
+      <p:sp>
+        <p:nvSpPr>
+          <p:cNvPr id="6" name="TextBox 5"/>
           <p:cNvSpPr txBox="1"/>
           <p:nvPr/>
         </p:nvSpPr>
         <p:spPr>
           <a:xfrm>
-            <a:off x="914400" y="5376672"/>
-            <a:ext cx="10362895" cy="822960"/>
+            <a:off x="7132320" y="1353312"/>
+            <a:ext cx="4144975" cy="1371600"/>
           </a:xfrm>
           <a:prstGeom prst="rect">
             <a:avLst/>
@@ -6411,37 +6456,247 @@
               <a:spcAft>
                 <a:spcPts val="200"/>
               </a:spcAft>
-              <a:defRPr b="1" sz="1000">
+              <a:defRPr b="1" sz="1100">
+                <a:solidFill>
+                  <a:srgbClr val="1E40AF"/>
+                </a:solidFill>
+              </a:defRPr>
+            </a:pPr>
+            <a:r>
+              <a:t>1. FRONTLINE INGESTION &amp; CLIENT TIER</a:t>
+            </a:r>
+          </a:p>
+          <a:p>
+            <a:pPr>
+              <a:defRPr sz="950">
+                <a:solidFill>
+                  <a:srgbClr val="0F172A"/>
+                </a:solidFill>
+              </a:defRPr>
+            </a:pPr>
+            <a:r>
+              <a:t>• ASHA / ANM Cadre: Voice memos streamed in 22 Indic dialects via Web Speech &amp; Indic Audio Processor -&gt; Google Cloud STT &amp; Translation.</a:t>
+            </a:r>
+            <a:br/>
+            <a:r>
+              <a:t>• PHC Dispensaries: Physical register ledgers digitized locally via Camera OCR component -&gt; Gemini 1.5 Flash Vision.</a:t>
+            </a:r>
+            <a:br/>
+            <a:r>
+              <a:t>• Executive Deck: One-click e-Challan approvals by DHOs and real-time MoHFW national resilience monitoring.</a:t>
+            </a:r>
+          </a:p>
+        </p:txBody>
+      </p:sp>
+      <p:sp>
+        <p:nvSpPr>
+          <p:cNvPr id="7" name="Rounded Rectangle 6"/>
+          <p:cNvSpPr/>
+          <p:nvPr/>
+        </p:nvSpPr>
+        <p:spPr>
+          <a:xfrm>
+            <a:off x="6949440" y="2999232"/>
+            <a:ext cx="4510735" cy="1536192"/>
+          </a:xfrm>
+          <a:prstGeom prst="roundRect">
+            <a:avLst/>
+          </a:prstGeom>
+          <a:solidFill>
+            <a:srgbClr val="ECFDF5"/>
+          </a:solidFill>
+          <a:ln w="12700">
+            <a:solidFill>
+              <a:srgbClr val="A7F3D0"/>
+            </a:solidFill>
+          </a:ln>
+        </p:spPr>
+        <p:style>
+          <a:lnRef idx="1">
+            <a:schemeClr val="accent1"/>
+          </a:lnRef>
+          <a:fillRef idx="3">
+            <a:schemeClr val="accent1"/>
+          </a:fillRef>
+          <a:effectRef idx="2">
+            <a:schemeClr val="accent1"/>
+          </a:effectRef>
+          <a:fontRef idx="minor">
+            <a:schemeClr val="lt1"/>
+          </a:fontRef>
+        </p:style>
+        <p:txBody>
+          <a:bodyPr rtlCol="0" anchor="ctr"/>
+          <a:lstStyle/>
+          <a:p>
+            <a:pPr algn="ctr"/>
+          </a:p>
+        </p:txBody>
+      </p:sp>
+      <p:sp>
+        <p:nvSpPr>
+          <p:cNvPr id="8" name="TextBox 7"/>
+          <p:cNvSpPr txBox="1"/>
+          <p:nvPr/>
+        </p:nvSpPr>
+        <p:spPr>
+          <a:xfrm>
+            <a:off x="7132320" y="3072384"/>
+            <a:ext cx="4144975" cy="1371600"/>
+          </a:xfrm>
+          <a:prstGeom prst="rect">
+            <a:avLst/>
+          </a:prstGeom>
+          <a:noFill/>
+        </p:spPr>
+        <p:txBody>
+          <a:bodyPr wrap="square">
+            <a:spAutoFit/>
+          </a:bodyPr>
+          <a:lstStyle/>
+          <a:p>
+            <a:pPr>
+              <a:spcAft>
+                <a:spcPts val="200"/>
+              </a:spcAft>
+              <a:defRPr b="1" sz="1100">
                 <a:solidFill>
                   <a:srgbClr val="059669"/>
                 </a:solidFill>
               </a:defRPr>
             </a:pPr>
             <a:r>
-              <a:t>CORE TELEMETRY PATHWAYS:</a:t>
-            </a:r>
-          </a:p>
-          <a:p>
-            <a:pPr>
-              <a:defRPr sz="1050">
+              <a:t>2. CORE API &amp; ORCHESTRATION ENGINE</a:t>
+            </a:r>
+          </a:p>
+          <a:p>
+            <a:pPr>
+              <a:defRPr sz="950">
                 <a:solidFill>
                   <a:srgbClr val="0F172A"/>
                 </a:solidFill>
               </a:defRPr>
             </a:pPr>
             <a:r>
-              <a:t>• Voice &amp; OCR Ingestion: ASHA voice memos and PHC ledger photos flow via Web Speech/Canvas to FastAPI -&gt; Gemini 1.5 Flash Vision &amp; STT.</a:t>
+              <a:t>• FastAPI 0.111 Service: Central asynchronous gateway handling request validation, queue routing, and telemetry dispatch.</a:t>
             </a:r>
             <a:br/>
             <a:r>
-              <a:t>• Logistics &amp; Surveillance: DHO approvals and MoHFW telemetry route through Vertex AI demand matching and BigQuery public health bridges.</a:t>
-            </a:r>
-          </a:p>
-        </p:txBody>
-      </p:sp>
-      <p:sp>
-        <p:nvSpPr>
-          <p:cNvPr id="6" name="TextBox 5"/>
+              <a:t>• Vertex AI Demand Engine: Epidemiological time-series forecasting detecting surge patterns 14 days before stockouts.</a:t>
+            </a:r>
+            <a:br/>
+            <a:r>
+              <a:t>• FedAvg Aggregator: Sovereign federated weight aggregation ensuring zero raw patient data crosses state borders.</a:t>
+            </a:r>
+          </a:p>
+        </p:txBody>
+      </p:sp>
+      <p:sp>
+        <p:nvSpPr>
+          <p:cNvPr id="9" name="Rounded Rectangle 8"/>
+          <p:cNvSpPr/>
+          <p:nvPr/>
+        </p:nvSpPr>
+        <p:spPr>
+          <a:xfrm>
+            <a:off x="6949440" y="4718304"/>
+            <a:ext cx="4510735" cy="1536192"/>
+          </a:xfrm>
+          <a:prstGeom prst="roundRect">
+            <a:avLst/>
+          </a:prstGeom>
+          <a:solidFill>
+            <a:srgbClr val="F8FAFC"/>
+          </a:solidFill>
+          <a:ln w="12700">
+            <a:solidFill>
+              <a:srgbClr val="E2E8F0"/>
+            </a:solidFill>
+          </a:ln>
+        </p:spPr>
+        <p:style>
+          <a:lnRef idx="1">
+            <a:schemeClr val="accent1"/>
+          </a:lnRef>
+          <a:fillRef idx="3">
+            <a:schemeClr val="accent1"/>
+          </a:fillRef>
+          <a:effectRef idx="2">
+            <a:schemeClr val="accent1"/>
+          </a:effectRef>
+          <a:fontRef idx="minor">
+            <a:schemeClr val="lt1"/>
+          </a:fontRef>
+        </p:style>
+        <p:txBody>
+          <a:bodyPr rtlCol="0" anchor="ctr"/>
+          <a:lstStyle/>
+          <a:p>
+            <a:pPr algn="ctr"/>
+          </a:p>
+        </p:txBody>
+      </p:sp>
+      <p:sp>
+        <p:nvSpPr>
+          <p:cNvPr id="10" name="TextBox 9"/>
+          <p:cNvSpPr txBox="1"/>
+          <p:nvPr/>
+        </p:nvSpPr>
+        <p:spPr>
+          <a:xfrm>
+            <a:off x="7132320" y="4791456"/>
+            <a:ext cx="4144975" cy="1371600"/>
+          </a:xfrm>
+          <a:prstGeom prst="rect">
+            <a:avLst/>
+          </a:prstGeom>
+          <a:noFill/>
+        </p:spPr>
+        <p:txBody>
+          <a:bodyPr wrap="square">
+            <a:spAutoFit/>
+          </a:bodyPr>
+          <a:lstStyle/>
+          <a:p>
+            <a:pPr>
+              <a:spcAft>
+                <a:spcPts val="200"/>
+              </a:spcAft>
+              <a:defRPr b="1" sz="1100">
+                <a:solidFill>
+                  <a:srgbClr val="0F172A"/>
+                </a:solidFill>
+              </a:defRPr>
+            </a:pPr>
+            <a:r>
+              <a:t>3. ENTERPRISE CLOUD &amp; RESILIENT STORAGE</a:t>
+            </a:r>
+          </a:p>
+          <a:p>
+            <a:pPr>
+              <a:defRPr sz="950">
+                <a:solidFill>
+                  <a:srgbClr val="0F172A"/>
+                </a:solidFill>
+              </a:defRPr>
+            </a:pPr>
+            <a:r>
+              <a:t>• Google Cloud Integrations: Gemini 1.5 Flash/Pro, Cloud Translation, and BigQuery bridge for HMIS &amp; IDSP disease surveillance.</a:t>
+            </a:r>
+            <a:br/>
+            <a:r>
+              <a:t>• Hybrid Persistence: Local edge SQLite for offline rural resilience paired with production Cloud SQL PostgreSQL cluster.</a:t>
+            </a:r>
+            <a:br/>
+            <a:r>
+              <a:t>• Redis Caching: Distributed queue and rate limiter guaranteeing zero packet loss during connectivity dropouts.</a:t>
+            </a:r>
+          </a:p>
+        </p:txBody>
+      </p:sp>
+      <p:sp>
+        <p:nvSpPr>
+          <p:cNvPr id="11" name="TextBox 10"/>
           <p:cNvSpPr txBox="1"/>
           <p:nvPr/>
         </p:nvSpPr>

</xml_diff>